<commit_message>
Update week 4 assignment and week 5 schedule, proposal templates
</commit_message>
<xml_diff>
--- a/week08/lecture/08_project_proposal_guide.pptx
+++ b/week08/lecture/08_project_proposal_guide.pptx
@@ -2,28 +2,28 @@
 <file path=ppt/presentation.xml><?xml version="1.0" encoding="utf-8"?>
 <p:presentation xmlns:p="http://schemas.openxmlformats.org/presentationml/2006/main">
   <p:sldMasterIdLst>
-    <p:sldMasterId xmlns:r="http://schemas.openxmlformats.org/officeDocument/2006/relationships" id="2147483648" r:id="R70532ee4b1694a4e"/>
+    <p:sldMasterId xmlns:r="http://schemas.openxmlformats.org/officeDocument/2006/relationships" id="2147483648" r:id="Rc32d4f8bba5240ae"/>
   </p:sldMasterIdLst>
   <p:notesMasterIdLst>
-    <p:notesMasterId xmlns:r="http://schemas.openxmlformats.org/officeDocument/2006/relationships" r:id="R51153e4b1d7f46ce"/>
+    <p:notesMasterId xmlns:r="http://schemas.openxmlformats.org/officeDocument/2006/relationships" r:id="R20597aa3f4534b2d"/>
   </p:notesMasterIdLst>
   <p:sldIdLst>
-    <p:sldId xmlns:r="http://schemas.openxmlformats.org/officeDocument/2006/relationships" id="256" r:id="Rd93a55b52c7a4e1c"/>
-    <p:sldId xmlns:r="http://schemas.openxmlformats.org/officeDocument/2006/relationships" id="257" r:id="R6c49c8268b7c4a3d"/>
-    <p:sldId xmlns:r="http://schemas.openxmlformats.org/officeDocument/2006/relationships" id="258" r:id="R538c9861abba4956"/>
-    <p:sldId xmlns:r="http://schemas.openxmlformats.org/officeDocument/2006/relationships" id="259" r:id="R89508d9c01a942fa"/>
-    <p:sldId xmlns:r="http://schemas.openxmlformats.org/officeDocument/2006/relationships" id="260" r:id="R7b7b0daf42614a11"/>
-    <p:sldId xmlns:r="http://schemas.openxmlformats.org/officeDocument/2006/relationships" id="261" r:id="R6992110766b94c66"/>
-    <p:sldId xmlns:r="http://schemas.openxmlformats.org/officeDocument/2006/relationships" id="262" r:id="R0cccb38fd60b4280"/>
-    <p:sldId xmlns:r="http://schemas.openxmlformats.org/officeDocument/2006/relationships" id="263" r:id="R24d560b4aad64869"/>
-    <p:sldId xmlns:r="http://schemas.openxmlformats.org/officeDocument/2006/relationships" id="264" r:id="Ra955ff6188f348f1"/>
-    <p:sldId xmlns:r="http://schemas.openxmlformats.org/officeDocument/2006/relationships" id="265" r:id="Re9e0b9faf17444ec"/>
-    <p:sldId xmlns:r="http://schemas.openxmlformats.org/officeDocument/2006/relationships" id="266" r:id="Rf5ab3860f9e34d18"/>
-    <p:sldId xmlns:r="http://schemas.openxmlformats.org/officeDocument/2006/relationships" id="267" r:id="Rc136075a670f424d"/>
-    <p:sldId xmlns:r="http://schemas.openxmlformats.org/officeDocument/2006/relationships" id="268" r:id="Rc3e3af0989af4168"/>
-    <p:sldId xmlns:r="http://schemas.openxmlformats.org/officeDocument/2006/relationships" id="269" r:id="Rde5919197c154b9c"/>
-    <p:sldId xmlns:r="http://schemas.openxmlformats.org/officeDocument/2006/relationships" id="270" r:id="R650133857b584057"/>
-    <p:sldId xmlns:r="http://schemas.openxmlformats.org/officeDocument/2006/relationships" id="271" r:id="R819f5464b6024917"/>
+    <p:sldId xmlns:r="http://schemas.openxmlformats.org/officeDocument/2006/relationships" id="256" r:id="R52d4d9aa882a4ebf"/>
+    <p:sldId xmlns:r="http://schemas.openxmlformats.org/officeDocument/2006/relationships" id="257" r:id="Rff20f04aa11642f2"/>
+    <p:sldId xmlns:r="http://schemas.openxmlformats.org/officeDocument/2006/relationships" id="258" r:id="R4be10dbdbbb642c3"/>
+    <p:sldId xmlns:r="http://schemas.openxmlformats.org/officeDocument/2006/relationships" id="259" r:id="R930a52c8086f475d"/>
+    <p:sldId xmlns:r="http://schemas.openxmlformats.org/officeDocument/2006/relationships" id="260" r:id="Rd76477cd6c7441a9"/>
+    <p:sldId xmlns:r="http://schemas.openxmlformats.org/officeDocument/2006/relationships" id="261" r:id="Rdc23c35952424b98"/>
+    <p:sldId xmlns:r="http://schemas.openxmlformats.org/officeDocument/2006/relationships" id="262" r:id="R78c353ee8d7a439d"/>
+    <p:sldId xmlns:r="http://schemas.openxmlformats.org/officeDocument/2006/relationships" id="263" r:id="R645dbab6998542dc"/>
+    <p:sldId xmlns:r="http://schemas.openxmlformats.org/officeDocument/2006/relationships" id="264" r:id="R37f06dc46607437d"/>
+    <p:sldId xmlns:r="http://schemas.openxmlformats.org/officeDocument/2006/relationships" id="265" r:id="Rdcfcfa8ddd7d4a26"/>
+    <p:sldId xmlns:r="http://schemas.openxmlformats.org/officeDocument/2006/relationships" id="266" r:id="R643e94ab4f764c28"/>
+    <p:sldId xmlns:r="http://schemas.openxmlformats.org/officeDocument/2006/relationships" id="267" r:id="Rd99e7ea388ad4fe2"/>
+    <p:sldId xmlns:r="http://schemas.openxmlformats.org/officeDocument/2006/relationships" id="268" r:id="Rc3f0faa289ed4118"/>
+    <p:sldId xmlns:r="http://schemas.openxmlformats.org/officeDocument/2006/relationships" id="269" r:id="Rf7ef78a129744dfd"/>
+    <p:sldId xmlns:r="http://schemas.openxmlformats.org/officeDocument/2006/relationships" id="270" r:id="Rb569824216ba4072"/>
+    <p:sldId xmlns:r="http://schemas.openxmlformats.org/officeDocument/2006/relationships" id="271" r:id="R979c1bc972334abf"/>
   </p:sldIdLst>
   <p:sldSz cx="12192000" cy="6858000"/>
   <p:notesSz cx="6858000" cy="9144000"/>
@@ -1257,7 +1257,7 @@
           <a:lstStyle xmlns:a="http://schemas.openxmlformats.org/drawingml/2006/main"/>
           <a:p xmlns:a="http://schemas.openxmlformats.org/drawingml/2006/main">
             <a:r>
-              <a:t>8주차 기획서 제출. 도식이나 예시를 먼저 관찰한 뒤 수강생에게 결과 예측을 요청한다. 구분 · 구성·제출 · 아주대AI대학원 · 2–4인 자율 팀 · 팀 지원 URL 등록 · LMS 제출 · 군산대·국립창원대 등 · 개인 기획서 · 이메일 제출 · 공통 · 10.23 온라인 제출·평가 · 실시간 수업·중간고사 없음 · 형식 · HTML·Word·PDF·PPT 자유 · 열리는 링크·파일 확인. 실습 단계에서는 같은 조건으로 실행하고 한 변수만 변경해 기록한다. 교육용 합성 자료와 실제 모델 실행 범위를 구분하며, 확인되지 않은 일반 성능을 주장하지 않는다.</a:t>
+              <a:t>8주차 기획서 제출. 도식이나 예시를 먼저 관찰한 뒤 수강생에게 결과 예측을 요청한다. 구분 · 구성·제출 · 아주대AI대학원 · 2–4인 자율 팀 · 지원 URL · LMS 제출 · 군산대·국립창원대 등 · 개인 진행 가능 · 공지된 교수 이메일 제출 · 7주차 · 10.16 · 초안 먼저 제출 · 교수 피드백 후 수정 · 8주차 · 10.23 · 수정본 온라인 제출·평가 · 시험 없음 · 형식 · PPT·Word·PDF·HTML 가능 · 한글(HWP) 제외. 실습 단계에서는 같은 조건으로 실행하고 한 변수만 변경해 기록한다. 교육용 합성 자료와 실제 모델 실행 범위를 구분하며, 확인되지 않은 일반 성능을 주장하지 않는다.</a:t>
             </a:r>
           </a:p>
           <a:p xmlns:a="http://schemas.openxmlformats.org/drawingml/2006/main">
@@ -2055,7 +2055,7 @@
   </p:cSld>
   <p:clrMap bg1="lt1" tx1="dk1" bg2="lt2" tx2="dk2" accent1="accent1" accent2="accent2" accent3="accent3" accent4="accent4" accent5="accent5" accent6="accent6" hlink="hlink" folHlink="folHlink"/>
   <p:sldLayoutIdLst>
-    <p:sldLayoutId xmlns:r="http://schemas.openxmlformats.org/officeDocument/2006/relationships" id="2147483649" r:id="Rec01d487106c488f"/>
+    <p:sldLayoutId xmlns:r="http://schemas.openxmlformats.org/officeDocument/2006/relationships" id="2147483649" r:id="R9bfef4ea07f644d0"/>
   </p:sldLayoutIdLst>
   <p:txStyles>
     <p:titleStyle>
@@ -2606,7 +2606,7 @@
           <p:cNvPr id="7" name="">
             <a:extLst xmlns:a="http://schemas.openxmlformats.org/drawingml/2006/main">
               <a:ext uri="{FF2B5EF4-FFF2-40B4-BE49-F238E27FC236}">
-                <a16:creationId xmlns:a16="http://schemas.microsoft.com/office/drawing/2014/main" id="{2F93F6E0-7C68-427E-86C1-FCAD8714928B}"/>
+                <a16:creationId xmlns:a16="http://schemas.microsoft.com/office/drawing/2014/main" id="{6CE6C34B-C042-44B4-B948-D372726DFF09}"/>
               </a:ext>
             </a:extLst>
           </p:cNvPr>
@@ -2668,7 +2668,7 @@
           <p:cNvPr id="2" name="">
             <a:extLst xmlns:a="http://schemas.openxmlformats.org/drawingml/2006/main">
               <a:ext uri="{FF2B5EF4-FFF2-40B4-BE49-F238E27FC236}">
-                <a16:creationId xmlns:a16="http://schemas.microsoft.com/office/drawing/2014/main" id="{B3BDA3FF-7715-4350-A403-2FBDAE5AD26A}"/>
+                <a16:creationId xmlns:a16="http://schemas.microsoft.com/office/drawing/2014/main" id="{60E83CF1-EE52-47DF-8B04-63BE37CDBD12}"/>
               </a:ext>
             </a:extLst>
           </p:cNvPr>
@@ -2730,7 +2730,7 @@
           <p:cNvPr id="3" name="">
             <a:extLst xmlns:a="http://schemas.openxmlformats.org/drawingml/2006/main">
               <a:ext uri="{FF2B5EF4-FFF2-40B4-BE49-F238E27FC236}">
-                <a16:creationId xmlns:a16="http://schemas.microsoft.com/office/drawing/2014/main" id="{D68CBE3A-12C9-47D7-86E5-016A721327C4}"/>
+                <a16:creationId xmlns:a16="http://schemas.microsoft.com/office/drawing/2014/main" id="{3405B17D-2416-470D-8A66-C6753BBB993A}"/>
               </a:ext>
             </a:extLst>
           </p:cNvPr>
@@ -2761,7 +2761,7 @@
           <p:cNvPr id="4" name="">
             <a:extLst xmlns:a="http://schemas.openxmlformats.org/drawingml/2006/main">
               <a:ext uri="{FF2B5EF4-FFF2-40B4-BE49-F238E27FC236}">
-                <a16:creationId xmlns:a16="http://schemas.microsoft.com/office/drawing/2014/main" id="{9C19D6F7-92F6-40C1-ADA4-7EB84E7C7EE7}"/>
+                <a16:creationId xmlns:a16="http://schemas.microsoft.com/office/drawing/2014/main" id="{64C6B1D1-0BB1-4ED8-90E3-179375D5245B}"/>
               </a:ext>
             </a:extLst>
           </p:cNvPr>
@@ -2823,7 +2823,7 @@
           <p:cNvPr id="5" name="">
             <a:extLst xmlns:a="http://schemas.openxmlformats.org/drawingml/2006/main">
               <a:ext uri="{FF2B5EF4-FFF2-40B4-BE49-F238E27FC236}">
-                <a16:creationId xmlns:a16="http://schemas.microsoft.com/office/drawing/2014/main" id="{FF8FD19A-E855-4277-87A7-36ED67ADB439}"/>
+                <a16:creationId xmlns:a16="http://schemas.microsoft.com/office/drawing/2014/main" id="{710F3ED6-CCEB-4EE0-B7E4-564DA5B5CD12}"/>
               </a:ext>
             </a:extLst>
           </p:cNvPr>
@@ -2885,7 +2885,7 @@
           <p:cNvPr id="6" name="">
             <a:extLst xmlns:a="http://schemas.openxmlformats.org/drawingml/2006/main">
               <a:ext uri="{FF2B5EF4-FFF2-40B4-BE49-F238E27FC236}">
-                <a16:creationId xmlns:a16="http://schemas.microsoft.com/office/drawing/2014/main" id="{C3D92D0D-96D1-412D-804F-43C80C19D5EC}"/>
+                <a16:creationId xmlns:a16="http://schemas.microsoft.com/office/drawing/2014/main" id="{B59608FA-CF7B-48D0-B749-9A303D13E830}"/>
               </a:ext>
             </a:extLst>
           </p:cNvPr>
@@ -2945,7 +2945,7 @@
     </p:spTree>
     <p:extLst>
       <p:ext uri="{BB962C8B-B14F-4D97-AF65-F5344CB8AC3E}">
-        <p14:creationId xmlns:p14="http://schemas.microsoft.com/office/powerpoint/2010/main" val="1165489669"/>
+        <p14:creationId xmlns:p14="http://schemas.microsoft.com/office/powerpoint/2010/main" val="1731831963"/>
       </p:ext>
     </p:extLst>
   </p:cSld>
@@ -2976,7 +2976,7 @@
           <p:cNvPr id="22" name="">
             <a:extLst xmlns:a="http://schemas.openxmlformats.org/drawingml/2006/main">
               <a:ext uri="{FF2B5EF4-FFF2-40B4-BE49-F238E27FC236}">
-                <a16:creationId xmlns:a16="http://schemas.microsoft.com/office/drawing/2014/main" id="{4969E194-A618-4968-BAB9-4D7A62C2397D}"/>
+                <a16:creationId xmlns:a16="http://schemas.microsoft.com/office/drawing/2014/main" id="{6E6EEE9D-7ACB-4497-BDD6-20A018AAFB7B}"/>
               </a:ext>
             </a:extLst>
           </p:cNvPr>
@@ -3038,7 +3038,7 @@
           <p:cNvPr id="2" name="">
             <a:extLst xmlns:a="http://schemas.openxmlformats.org/drawingml/2006/main">
               <a:ext uri="{FF2B5EF4-FFF2-40B4-BE49-F238E27FC236}">
-                <a16:creationId xmlns:a16="http://schemas.microsoft.com/office/drawing/2014/main" id="{D0DB6C58-E767-4265-8111-64CE76C96A0E}"/>
+                <a16:creationId xmlns:a16="http://schemas.microsoft.com/office/drawing/2014/main" id="{2FDED020-0985-46ED-BD74-8C88DCAEE238}"/>
               </a:ext>
             </a:extLst>
           </p:cNvPr>
@@ -3100,7 +3100,7 @@
           <p:cNvPr id="3" name="">
             <a:extLst xmlns:a="http://schemas.openxmlformats.org/drawingml/2006/main">
               <a:ext uri="{FF2B5EF4-FFF2-40B4-BE49-F238E27FC236}">
-                <a16:creationId xmlns:a16="http://schemas.microsoft.com/office/drawing/2014/main" id="{DF29085E-FAB7-417A-B18B-72D53A98D64A}"/>
+                <a16:creationId xmlns:a16="http://schemas.microsoft.com/office/drawing/2014/main" id="{BBA45F11-AF35-45CB-A06A-1F1E985DBB9D}"/>
               </a:ext>
             </a:extLst>
           </p:cNvPr>
@@ -3162,7 +3162,7 @@
           <p:cNvPr id="4" name="">
             <a:extLst xmlns:a="http://schemas.openxmlformats.org/drawingml/2006/main">
               <a:ext uri="{FF2B5EF4-FFF2-40B4-BE49-F238E27FC236}">
-                <a16:creationId xmlns:a16="http://schemas.microsoft.com/office/drawing/2014/main" id="{857D07F1-A110-4AFF-A60A-EA6D7AF149DC}"/>
+                <a16:creationId xmlns:a16="http://schemas.microsoft.com/office/drawing/2014/main" id="{0C20C5EA-2C72-4003-B970-DC7262FF8A77}"/>
               </a:ext>
             </a:extLst>
           </p:cNvPr>
@@ -3193,7 +3193,7 @@
           <p:cNvPr id="5" name="">
             <a:extLst xmlns:a="http://schemas.openxmlformats.org/drawingml/2006/main">
               <a:ext uri="{FF2B5EF4-FFF2-40B4-BE49-F238E27FC236}">
-                <a16:creationId xmlns:a16="http://schemas.microsoft.com/office/drawing/2014/main" id="{3BDC9777-5250-4BF9-80D2-71B195AC88D2}"/>
+                <a16:creationId xmlns:a16="http://schemas.microsoft.com/office/drawing/2014/main" id="{D15C377B-DE33-43FB-8589-6DBA26EAB24D}"/>
               </a:ext>
             </a:extLst>
           </p:cNvPr>
@@ -3255,7 +3255,7 @@
           <p:cNvPr id="6" name="">
             <a:extLst xmlns:a="http://schemas.openxmlformats.org/drawingml/2006/main">
               <a:ext uri="{FF2B5EF4-FFF2-40B4-BE49-F238E27FC236}">
-                <a16:creationId xmlns:a16="http://schemas.microsoft.com/office/drawing/2014/main" id="{6369FD9D-2973-4B3D-B131-2A457CDC33FE}"/>
+                <a16:creationId xmlns:a16="http://schemas.microsoft.com/office/drawing/2014/main" id="{6AB7EC87-2D6C-472F-B2D3-2B3D82E338EB}"/>
               </a:ext>
             </a:extLst>
           </p:cNvPr>
@@ -3288,7 +3288,7 @@
           <p:cNvPr id="7" name="">
             <a:extLst xmlns:a="http://schemas.openxmlformats.org/drawingml/2006/main">
               <a:ext uri="{FF2B5EF4-FFF2-40B4-BE49-F238E27FC236}">
-                <a16:creationId xmlns:a16="http://schemas.microsoft.com/office/drawing/2014/main" id="{80B2056C-5F84-426F-8669-7EF8730D38AE}"/>
+                <a16:creationId xmlns:a16="http://schemas.microsoft.com/office/drawing/2014/main" id="{0D3383C0-0044-4089-A422-B2CA8B165563}"/>
               </a:ext>
             </a:extLst>
           </p:cNvPr>
@@ -3350,7 +3350,7 @@
           <p:cNvPr id="8" name="">
             <a:extLst xmlns:a="http://schemas.openxmlformats.org/drawingml/2006/main">
               <a:ext uri="{FF2B5EF4-FFF2-40B4-BE49-F238E27FC236}">
-                <a16:creationId xmlns:a16="http://schemas.microsoft.com/office/drawing/2014/main" id="{85C59DAB-4143-4DBB-8620-66F5342E1989}"/>
+                <a16:creationId xmlns:a16="http://schemas.microsoft.com/office/drawing/2014/main" id="{1637F79E-91B8-42DA-83D5-A7912F94467E}"/>
               </a:ext>
             </a:extLst>
           </p:cNvPr>
@@ -3412,7 +3412,7 @@
           <p:cNvPr id="9" name="">
             <a:extLst xmlns:a="http://schemas.openxmlformats.org/drawingml/2006/main">
               <a:ext uri="{FF2B5EF4-FFF2-40B4-BE49-F238E27FC236}">
-                <a16:creationId xmlns:a16="http://schemas.microsoft.com/office/drawing/2014/main" id="{4FC2EFF1-6A23-4984-AB82-5CDF00BE50E1}"/>
+                <a16:creationId xmlns:a16="http://schemas.microsoft.com/office/drawing/2014/main" id="{2CDFC76A-0BFD-4FE4-B537-D607BE4B0E20}"/>
               </a:ext>
             </a:extLst>
           </p:cNvPr>
@@ -3445,7 +3445,7 @@
           <p:cNvPr id="10" name="">
             <a:extLst xmlns:a="http://schemas.openxmlformats.org/drawingml/2006/main">
               <a:ext uri="{FF2B5EF4-FFF2-40B4-BE49-F238E27FC236}">
-                <a16:creationId xmlns:a16="http://schemas.microsoft.com/office/drawing/2014/main" id="{B1F7545B-3E1F-4AEB-BF24-BABF6C2F99F9}"/>
+                <a16:creationId xmlns:a16="http://schemas.microsoft.com/office/drawing/2014/main" id="{E61CC8EA-6890-4773-BB8E-0964AD3A0D3D}"/>
               </a:ext>
             </a:extLst>
           </p:cNvPr>
@@ -3507,7 +3507,7 @@
           <p:cNvPr id="11" name="">
             <a:extLst xmlns:a="http://schemas.openxmlformats.org/drawingml/2006/main">
               <a:ext uri="{FF2B5EF4-FFF2-40B4-BE49-F238E27FC236}">
-                <a16:creationId xmlns:a16="http://schemas.microsoft.com/office/drawing/2014/main" id="{9EA951BE-ACAA-4458-9595-B3DA7785BD09}"/>
+                <a16:creationId xmlns:a16="http://schemas.microsoft.com/office/drawing/2014/main" id="{76357252-5821-459E-B23C-81D56849763D}"/>
               </a:ext>
             </a:extLst>
           </p:cNvPr>
@@ -3569,7 +3569,7 @@
           <p:cNvPr id="12" name="">
             <a:extLst xmlns:a="http://schemas.openxmlformats.org/drawingml/2006/main">
               <a:ext uri="{FF2B5EF4-FFF2-40B4-BE49-F238E27FC236}">
-                <a16:creationId xmlns:a16="http://schemas.microsoft.com/office/drawing/2014/main" id="{B4AEE963-2F18-4CD6-BD09-2D5BAEB797D1}"/>
+                <a16:creationId xmlns:a16="http://schemas.microsoft.com/office/drawing/2014/main" id="{9E25212A-18CC-4FBA-9ADA-8BE7565C01A9}"/>
               </a:ext>
             </a:extLst>
           </p:cNvPr>
@@ -3602,7 +3602,7 @@
           <p:cNvPr id="13" name="">
             <a:extLst xmlns:a="http://schemas.openxmlformats.org/drawingml/2006/main">
               <a:ext uri="{FF2B5EF4-FFF2-40B4-BE49-F238E27FC236}">
-                <a16:creationId xmlns:a16="http://schemas.microsoft.com/office/drawing/2014/main" id="{29164F15-D008-47C7-9AE5-AD69BEEA3A1F}"/>
+                <a16:creationId xmlns:a16="http://schemas.microsoft.com/office/drawing/2014/main" id="{552E3EF9-F684-4B26-9B36-A462E5B8B26C}"/>
               </a:ext>
             </a:extLst>
           </p:cNvPr>
@@ -3664,7 +3664,7 @@
           <p:cNvPr id="14" name="">
             <a:extLst xmlns:a="http://schemas.openxmlformats.org/drawingml/2006/main">
               <a:ext uri="{FF2B5EF4-FFF2-40B4-BE49-F238E27FC236}">
-                <a16:creationId xmlns:a16="http://schemas.microsoft.com/office/drawing/2014/main" id="{6DFB20B9-065D-44A8-BFE7-4796F5F54886}"/>
+                <a16:creationId xmlns:a16="http://schemas.microsoft.com/office/drawing/2014/main" id="{62ABD92F-5979-4B12-97BE-052E723A7759}"/>
               </a:ext>
             </a:extLst>
           </p:cNvPr>
@@ -3726,7 +3726,7 @@
           <p:cNvPr id="15" name="">
             <a:extLst xmlns:a="http://schemas.openxmlformats.org/drawingml/2006/main">
               <a:ext uri="{FF2B5EF4-FFF2-40B4-BE49-F238E27FC236}">
-                <a16:creationId xmlns:a16="http://schemas.microsoft.com/office/drawing/2014/main" id="{2B306970-91DE-4B79-ACEE-A0E83B6B733E}"/>
+                <a16:creationId xmlns:a16="http://schemas.microsoft.com/office/drawing/2014/main" id="{CD25242D-094C-4A50-ADF7-C5DAD42FD1D6}"/>
               </a:ext>
             </a:extLst>
           </p:cNvPr>
@@ -3759,7 +3759,7 @@
           <p:cNvPr id="16" name="">
             <a:extLst xmlns:a="http://schemas.openxmlformats.org/drawingml/2006/main">
               <a:ext uri="{FF2B5EF4-FFF2-40B4-BE49-F238E27FC236}">
-                <a16:creationId xmlns:a16="http://schemas.microsoft.com/office/drawing/2014/main" id="{4E8D509B-68F4-401B-9398-A95EA9CCFD69}"/>
+                <a16:creationId xmlns:a16="http://schemas.microsoft.com/office/drawing/2014/main" id="{52CEAAD7-879D-476E-97B4-92FC5EDF9F57}"/>
               </a:ext>
             </a:extLst>
           </p:cNvPr>
@@ -3821,7 +3821,7 @@
           <p:cNvPr id="17" name="">
             <a:extLst xmlns:a="http://schemas.openxmlformats.org/drawingml/2006/main">
               <a:ext uri="{FF2B5EF4-FFF2-40B4-BE49-F238E27FC236}">
-                <a16:creationId xmlns:a16="http://schemas.microsoft.com/office/drawing/2014/main" id="{29D4CCE1-A241-4380-9D28-3270EC070660}"/>
+                <a16:creationId xmlns:a16="http://schemas.microsoft.com/office/drawing/2014/main" id="{9E18DF77-6FC0-47F8-9A36-9489EEC04923}"/>
               </a:ext>
             </a:extLst>
           </p:cNvPr>
@@ -3958,7 +3958,7 @@
           <p:cNvPr id="21" name="">
             <a:extLst xmlns:a="http://schemas.openxmlformats.org/drawingml/2006/main">
               <a:ext uri="{FF2B5EF4-FFF2-40B4-BE49-F238E27FC236}">
-                <a16:creationId xmlns:a16="http://schemas.microsoft.com/office/drawing/2014/main" id="{1BB379EC-4784-4858-9773-27E4E72DC720}"/>
+                <a16:creationId xmlns:a16="http://schemas.microsoft.com/office/drawing/2014/main" id="{7DD8F9CC-7B47-4EA1-B45E-F84FF40952CD}"/>
               </a:ext>
             </a:extLst>
           </p:cNvPr>
@@ -4018,7 +4018,7 @@
     </p:spTree>
     <p:extLst>
       <p:ext uri="{BB962C8B-B14F-4D97-AF65-F5344CB8AC3E}">
-        <p14:creationId xmlns:p14="http://schemas.microsoft.com/office/powerpoint/2010/main" val="403485276"/>
+        <p14:creationId xmlns:p14="http://schemas.microsoft.com/office/powerpoint/2010/main" val="1999358221"/>
       </p:ext>
     </p:extLst>
   </p:cSld>
@@ -4049,7 +4049,7 @@
           <p:cNvPr id="7" name="">
             <a:extLst xmlns:a="http://schemas.openxmlformats.org/drawingml/2006/main">
               <a:ext uri="{FF2B5EF4-FFF2-40B4-BE49-F238E27FC236}">
-                <a16:creationId xmlns:a16="http://schemas.microsoft.com/office/drawing/2014/main" id="{E10E2DD9-1BCD-4CFB-8083-35D639713216}"/>
+                <a16:creationId xmlns:a16="http://schemas.microsoft.com/office/drawing/2014/main" id="{98E669C4-2FD3-41FA-B26C-A193997AFB78}"/>
               </a:ext>
             </a:extLst>
           </p:cNvPr>
@@ -4111,7 +4111,7 @@
           <p:cNvPr id="2" name="">
             <a:extLst xmlns:a="http://schemas.openxmlformats.org/drawingml/2006/main">
               <a:ext uri="{FF2B5EF4-FFF2-40B4-BE49-F238E27FC236}">
-                <a16:creationId xmlns:a16="http://schemas.microsoft.com/office/drawing/2014/main" id="{1CE4A0A6-F618-4E75-8BC4-4D743D315E2F}"/>
+                <a16:creationId xmlns:a16="http://schemas.microsoft.com/office/drawing/2014/main" id="{D5ACD13A-E97A-48FE-AE7D-4D13ACFB8227}"/>
               </a:ext>
             </a:extLst>
           </p:cNvPr>
@@ -4173,7 +4173,7 @@
           <p:cNvPr id="3" name="">
             <a:extLst xmlns:a="http://schemas.openxmlformats.org/drawingml/2006/main">
               <a:ext uri="{FF2B5EF4-FFF2-40B4-BE49-F238E27FC236}">
-                <a16:creationId xmlns:a16="http://schemas.microsoft.com/office/drawing/2014/main" id="{34C53948-4E44-4F1E-BB69-05A735B35563}"/>
+                <a16:creationId xmlns:a16="http://schemas.microsoft.com/office/drawing/2014/main" id="{37BFA237-CAB6-414F-AD31-32CB5D7F8FF8}"/>
               </a:ext>
             </a:extLst>
           </p:cNvPr>
@@ -4235,7 +4235,7 @@
           <p:cNvPr id="4" name="">
             <a:extLst xmlns:a="http://schemas.openxmlformats.org/drawingml/2006/main">
               <a:ext uri="{FF2B5EF4-FFF2-40B4-BE49-F238E27FC236}">
-                <a16:creationId xmlns:a16="http://schemas.microsoft.com/office/drawing/2014/main" id="{1703BA6F-AF2A-4E69-802B-20DD53A0A511}"/>
+                <a16:creationId xmlns:a16="http://schemas.microsoft.com/office/drawing/2014/main" id="{301080EE-6A21-44A3-960E-FEBEB001410A}"/>
               </a:ext>
             </a:extLst>
           </p:cNvPr>
@@ -4266,7 +4266,7 @@
           <p:cNvPr id="5" name="">
             <a:extLst xmlns:a="http://schemas.openxmlformats.org/drawingml/2006/main">
               <a:ext uri="{FF2B5EF4-FFF2-40B4-BE49-F238E27FC236}">
-                <a16:creationId xmlns:a16="http://schemas.microsoft.com/office/drawing/2014/main" id="{0676F1ED-EA43-4269-8ED5-1EE45AC98601}"/>
+                <a16:creationId xmlns:a16="http://schemas.microsoft.com/office/drawing/2014/main" id="{B346E0E8-2F49-4085-B982-07BB79B3B4CD}"/>
               </a:ext>
             </a:extLst>
           </p:cNvPr>
@@ -4618,7 +4618,7 @@
     </p:spTree>
     <p:extLst>
       <p:ext uri="{BB962C8B-B14F-4D97-AF65-F5344CB8AC3E}">
-        <p14:creationId xmlns:p14="http://schemas.microsoft.com/office/powerpoint/2010/main" val="27721307"/>
+        <p14:creationId xmlns:p14="http://schemas.microsoft.com/office/powerpoint/2010/main" val="1651599773"/>
       </p:ext>
     </p:extLst>
   </p:cSld>
@@ -4649,7 +4649,7 @@
           <p:cNvPr id="24" name="">
             <a:extLst xmlns:a="http://schemas.openxmlformats.org/drawingml/2006/main">
               <a:ext uri="{FF2B5EF4-FFF2-40B4-BE49-F238E27FC236}">
-                <a16:creationId xmlns:a16="http://schemas.microsoft.com/office/drawing/2014/main" id="{ADC56D08-56F7-41B3-8791-659D8101E126}"/>
+                <a16:creationId xmlns:a16="http://schemas.microsoft.com/office/drawing/2014/main" id="{CAC4C685-07B2-40C1-BD32-C529864A87D8}"/>
               </a:ext>
             </a:extLst>
           </p:cNvPr>
@@ -4711,7 +4711,7 @@
           <p:cNvPr id="2" name="">
             <a:extLst xmlns:a="http://schemas.openxmlformats.org/drawingml/2006/main">
               <a:ext uri="{FF2B5EF4-FFF2-40B4-BE49-F238E27FC236}">
-                <a16:creationId xmlns:a16="http://schemas.microsoft.com/office/drawing/2014/main" id="{1621A7AC-E490-47D0-84D6-CB8D284EAB38}"/>
+                <a16:creationId xmlns:a16="http://schemas.microsoft.com/office/drawing/2014/main" id="{0AFAE9D1-FC84-4885-AF02-23C179A82267}"/>
               </a:ext>
             </a:extLst>
           </p:cNvPr>
@@ -4773,7 +4773,7 @@
           <p:cNvPr id="3" name="">
             <a:extLst xmlns:a="http://schemas.openxmlformats.org/drawingml/2006/main">
               <a:ext uri="{FF2B5EF4-FFF2-40B4-BE49-F238E27FC236}">
-                <a16:creationId xmlns:a16="http://schemas.microsoft.com/office/drawing/2014/main" id="{7493A437-6929-41D8-A874-2517913C0AA8}"/>
+                <a16:creationId xmlns:a16="http://schemas.microsoft.com/office/drawing/2014/main" id="{D9F82248-70C8-4458-9BDB-750261E4DEC9}"/>
               </a:ext>
             </a:extLst>
           </p:cNvPr>
@@ -4835,7 +4835,7 @@
           <p:cNvPr id="4" name="">
             <a:extLst xmlns:a="http://schemas.openxmlformats.org/drawingml/2006/main">
               <a:ext uri="{FF2B5EF4-FFF2-40B4-BE49-F238E27FC236}">
-                <a16:creationId xmlns:a16="http://schemas.microsoft.com/office/drawing/2014/main" id="{2E9115CF-3EF9-403D-8986-301E6C0E19F4}"/>
+                <a16:creationId xmlns:a16="http://schemas.microsoft.com/office/drawing/2014/main" id="{86123F2A-341D-4498-ACDC-FA7A5EC074A9}"/>
               </a:ext>
             </a:extLst>
           </p:cNvPr>
@@ -4866,7 +4866,7 @@
           <p:cNvPr id="5" name="">
             <a:extLst xmlns:a="http://schemas.openxmlformats.org/drawingml/2006/main">
               <a:ext uri="{FF2B5EF4-FFF2-40B4-BE49-F238E27FC236}">
-                <a16:creationId xmlns:a16="http://schemas.microsoft.com/office/drawing/2014/main" id="{95FEA44F-C381-4BD2-998E-3115C2F5AB4E}"/>
+                <a16:creationId xmlns:a16="http://schemas.microsoft.com/office/drawing/2014/main" id="{222B6A8B-0415-459A-84F0-7B2F5E0FAD2E}"/>
               </a:ext>
             </a:extLst>
           </p:cNvPr>
@@ -4928,7 +4928,7 @@
           <p:cNvPr id="6" name="">
             <a:extLst xmlns:a="http://schemas.openxmlformats.org/drawingml/2006/main">
               <a:ext uri="{FF2B5EF4-FFF2-40B4-BE49-F238E27FC236}">
-                <a16:creationId xmlns:a16="http://schemas.microsoft.com/office/drawing/2014/main" id="{4F62D9F2-84C3-4FD3-A2F4-5D30B67031BC}"/>
+                <a16:creationId xmlns:a16="http://schemas.microsoft.com/office/drawing/2014/main" id="{38D7B410-2F36-484C-BC47-035D01C12423}"/>
               </a:ext>
             </a:extLst>
           </p:cNvPr>
@@ -4990,7 +4990,7 @@
           <p:cNvPr id="7" name="">
             <a:extLst xmlns:a="http://schemas.openxmlformats.org/drawingml/2006/main">
               <a:ext uri="{FF2B5EF4-FFF2-40B4-BE49-F238E27FC236}">
-                <a16:creationId xmlns:a16="http://schemas.microsoft.com/office/drawing/2014/main" id="{1E10F4FC-5AA5-49F4-8FA2-E98087E7D614}"/>
+                <a16:creationId xmlns:a16="http://schemas.microsoft.com/office/drawing/2014/main" id="{72AA649D-B18D-48A0-98E6-BC5035E96E84}"/>
               </a:ext>
             </a:extLst>
           </p:cNvPr>
@@ -5023,7 +5023,7 @@
           <p:cNvPr id="8" name="">
             <a:extLst xmlns:a="http://schemas.openxmlformats.org/drawingml/2006/main">
               <a:ext uri="{FF2B5EF4-FFF2-40B4-BE49-F238E27FC236}">
-                <a16:creationId xmlns:a16="http://schemas.microsoft.com/office/drawing/2014/main" id="{3096A53D-654E-41C6-84DB-A19C1F77F000}"/>
+                <a16:creationId xmlns:a16="http://schemas.microsoft.com/office/drawing/2014/main" id="{F2CB74E3-E925-4D0D-8E66-BBD3CB66E441}"/>
               </a:ext>
             </a:extLst>
           </p:cNvPr>
@@ -5085,7 +5085,7 @@
           <p:cNvPr id="9" name="">
             <a:extLst xmlns:a="http://schemas.openxmlformats.org/drawingml/2006/main">
               <a:ext uri="{FF2B5EF4-FFF2-40B4-BE49-F238E27FC236}">
-                <a16:creationId xmlns:a16="http://schemas.microsoft.com/office/drawing/2014/main" id="{2C540D87-FCD4-4936-B4EB-4B365053C7C4}"/>
+                <a16:creationId xmlns:a16="http://schemas.microsoft.com/office/drawing/2014/main" id="{42B22B94-B3CB-4E9C-A01D-7ED052ECCDA1}"/>
               </a:ext>
             </a:extLst>
           </p:cNvPr>
@@ -5118,7 +5118,7 @@
           <p:cNvPr id="10" name="">
             <a:extLst xmlns:a="http://schemas.openxmlformats.org/drawingml/2006/main">
               <a:ext uri="{FF2B5EF4-FFF2-40B4-BE49-F238E27FC236}">
-                <a16:creationId xmlns:a16="http://schemas.microsoft.com/office/drawing/2014/main" id="{285C64A9-0371-4A1E-B581-438E1E6F6F2F}"/>
+                <a16:creationId xmlns:a16="http://schemas.microsoft.com/office/drawing/2014/main" id="{1AFA6F52-866B-492B-AA98-635A020570AD}"/>
               </a:ext>
             </a:extLst>
           </p:cNvPr>
@@ -5180,7 +5180,7 @@
           <p:cNvPr id="11" name="">
             <a:extLst xmlns:a="http://schemas.openxmlformats.org/drawingml/2006/main">
               <a:ext uri="{FF2B5EF4-FFF2-40B4-BE49-F238E27FC236}">
-                <a16:creationId xmlns:a16="http://schemas.microsoft.com/office/drawing/2014/main" id="{8D372039-4826-467C-B690-AB3F71FF2E7C}"/>
+                <a16:creationId xmlns:a16="http://schemas.microsoft.com/office/drawing/2014/main" id="{7764A312-BCD5-42C7-98E1-3E92B73543D0}"/>
               </a:ext>
             </a:extLst>
           </p:cNvPr>
@@ -5213,7 +5213,7 @@
           <p:cNvPr id="12" name="">
             <a:extLst xmlns:a="http://schemas.openxmlformats.org/drawingml/2006/main">
               <a:ext uri="{FF2B5EF4-FFF2-40B4-BE49-F238E27FC236}">
-                <a16:creationId xmlns:a16="http://schemas.microsoft.com/office/drawing/2014/main" id="{09F2B2C6-9901-46DA-8F4E-A30619C893CD}"/>
+                <a16:creationId xmlns:a16="http://schemas.microsoft.com/office/drawing/2014/main" id="{B0F7822D-F170-4EA4-BA39-FDB4A5714428}"/>
               </a:ext>
             </a:extLst>
           </p:cNvPr>
@@ -5325,7 +5325,7 @@
           <p:cNvPr id="15" name="">
             <a:extLst xmlns:a="http://schemas.openxmlformats.org/drawingml/2006/main">
               <a:ext uri="{FF2B5EF4-FFF2-40B4-BE49-F238E27FC236}">
-                <a16:creationId xmlns:a16="http://schemas.microsoft.com/office/drawing/2014/main" id="{610A039B-AAAF-4460-8805-53365420EFD4}"/>
+                <a16:creationId xmlns:a16="http://schemas.microsoft.com/office/drawing/2014/main" id="{3D957D97-B6BC-41FA-86FF-109932F14C05}"/>
               </a:ext>
             </a:extLst>
           </p:cNvPr>
@@ -5387,7 +5387,7 @@
           <p:cNvPr id="16" name="">
             <a:extLst xmlns:a="http://schemas.openxmlformats.org/drawingml/2006/main">
               <a:ext uri="{FF2B5EF4-FFF2-40B4-BE49-F238E27FC236}">
-                <a16:creationId xmlns:a16="http://schemas.microsoft.com/office/drawing/2014/main" id="{95C06BAA-0B7C-4512-A451-BBBB4C7DF56E}"/>
+                <a16:creationId xmlns:a16="http://schemas.microsoft.com/office/drawing/2014/main" id="{A4AF34A3-3DFE-404E-AA11-034B3606F14C}"/>
               </a:ext>
             </a:extLst>
           </p:cNvPr>
@@ -5420,7 +5420,7 @@
           <p:cNvPr id="17" name="">
             <a:extLst xmlns:a="http://schemas.openxmlformats.org/drawingml/2006/main">
               <a:ext uri="{FF2B5EF4-FFF2-40B4-BE49-F238E27FC236}">
-                <a16:creationId xmlns:a16="http://schemas.microsoft.com/office/drawing/2014/main" id="{5F9EE0DF-1884-41EB-807C-3AC286404D30}"/>
+                <a16:creationId xmlns:a16="http://schemas.microsoft.com/office/drawing/2014/main" id="{D32EE139-E294-46D2-BDFD-8F9E472A9493}"/>
               </a:ext>
             </a:extLst>
           </p:cNvPr>
@@ -5482,7 +5482,7 @@
           <p:cNvPr id="18" name="">
             <a:extLst xmlns:a="http://schemas.openxmlformats.org/drawingml/2006/main">
               <a:ext uri="{FF2B5EF4-FFF2-40B4-BE49-F238E27FC236}">
-                <a16:creationId xmlns:a16="http://schemas.microsoft.com/office/drawing/2014/main" id="{988837F0-7A38-4129-A397-4C123E6A7FA6}"/>
+                <a16:creationId xmlns:a16="http://schemas.microsoft.com/office/drawing/2014/main" id="{A17F9D63-4A88-44DB-902C-D1DF39C1D8EE}"/>
               </a:ext>
             </a:extLst>
           </p:cNvPr>
@@ -5515,7 +5515,7 @@
           <p:cNvPr id="19" name="">
             <a:extLst xmlns:a="http://schemas.openxmlformats.org/drawingml/2006/main">
               <a:ext uri="{FF2B5EF4-FFF2-40B4-BE49-F238E27FC236}">
-                <a16:creationId xmlns:a16="http://schemas.microsoft.com/office/drawing/2014/main" id="{A5FDC382-1A20-411D-8240-E0F132D75912}"/>
+                <a16:creationId xmlns:a16="http://schemas.microsoft.com/office/drawing/2014/main" id="{7DC25019-3D19-4C72-B9BF-FEB8A342B90F}"/>
               </a:ext>
             </a:extLst>
           </p:cNvPr>
@@ -5577,7 +5577,7 @@
           <p:cNvPr id="20" name="">
             <a:extLst xmlns:a="http://schemas.openxmlformats.org/drawingml/2006/main">
               <a:ext uri="{FF2B5EF4-FFF2-40B4-BE49-F238E27FC236}">
-                <a16:creationId xmlns:a16="http://schemas.microsoft.com/office/drawing/2014/main" id="{F3E7D660-D405-4B9D-BE5C-2C862DBFF35C}"/>
+                <a16:creationId xmlns:a16="http://schemas.microsoft.com/office/drawing/2014/main" id="{BCA80B5D-3069-497A-BCD6-38856ECF9159}"/>
               </a:ext>
             </a:extLst>
           </p:cNvPr>
@@ -5610,7 +5610,7 @@
           <p:cNvPr id="21" name="">
             <a:extLst xmlns:a="http://schemas.openxmlformats.org/drawingml/2006/main">
               <a:ext uri="{FF2B5EF4-FFF2-40B4-BE49-F238E27FC236}">
-                <a16:creationId xmlns:a16="http://schemas.microsoft.com/office/drawing/2014/main" id="{5022C88B-B14C-4A22-B153-BAAC25841C11}"/>
+                <a16:creationId xmlns:a16="http://schemas.microsoft.com/office/drawing/2014/main" id="{00DDC935-F930-4FCD-BF09-ED53549BF8C5}"/>
               </a:ext>
             </a:extLst>
           </p:cNvPr>
@@ -5720,7 +5720,7 @@
     </p:spTree>
     <p:extLst>
       <p:ext uri="{BB962C8B-B14F-4D97-AF65-F5344CB8AC3E}">
-        <p14:creationId xmlns:p14="http://schemas.microsoft.com/office/powerpoint/2010/main" val="1345629586"/>
+        <p14:creationId xmlns:p14="http://schemas.microsoft.com/office/powerpoint/2010/main" val="2096221138"/>
       </p:ext>
     </p:extLst>
   </p:cSld>
@@ -5751,7 +5751,7 @@
           <p:cNvPr id="18" name="">
             <a:extLst xmlns:a="http://schemas.openxmlformats.org/drawingml/2006/main">
               <a:ext uri="{FF2B5EF4-FFF2-40B4-BE49-F238E27FC236}">
-                <a16:creationId xmlns:a16="http://schemas.microsoft.com/office/drawing/2014/main" id="{007F26B2-A016-4A00-B101-AACEFC12ACB0}"/>
+                <a16:creationId xmlns:a16="http://schemas.microsoft.com/office/drawing/2014/main" id="{D72B1A75-12FE-4C7F-8973-FD617D6072FC}"/>
               </a:ext>
             </a:extLst>
           </p:cNvPr>
@@ -5813,7 +5813,7 @@
           <p:cNvPr id="2" name="">
             <a:extLst xmlns:a="http://schemas.openxmlformats.org/drawingml/2006/main">
               <a:ext uri="{FF2B5EF4-FFF2-40B4-BE49-F238E27FC236}">
-                <a16:creationId xmlns:a16="http://schemas.microsoft.com/office/drawing/2014/main" id="{043AE8C2-9FFC-44BA-9320-C695008DE66F}"/>
+                <a16:creationId xmlns:a16="http://schemas.microsoft.com/office/drawing/2014/main" id="{D762D7DF-D4C8-435B-AF01-BFBF6DFE7AE1}"/>
               </a:ext>
             </a:extLst>
           </p:cNvPr>
@@ -5875,7 +5875,7 @@
           <p:cNvPr id="3" name="">
             <a:extLst xmlns:a="http://schemas.openxmlformats.org/drawingml/2006/main">
               <a:ext uri="{FF2B5EF4-FFF2-40B4-BE49-F238E27FC236}">
-                <a16:creationId xmlns:a16="http://schemas.microsoft.com/office/drawing/2014/main" id="{A4CFEB6D-20EF-4348-97EC-A08F83BCCA54}"/>
+                <a16:creationId xmlns:a16="http://schemas.microsoft.com/office/drawing/2014/main" id="{F1C85FF8-B75F-4DF0-9167-7808DEB6C0B5}"/>
               </a:ext>
             </a:extLst>
           </p:cNvPr>
@@ -5937,7 +5937,7 @@
           <p:cNvPr id="4" name="">
             <a:extLst xmlns:a="http://schemas.openxmlformats.org/drawingml/2006/main">
               <a:ext uri="{FF2B5EF4-FFF2-40B4-BE49-F238E27FC236}">
-                <a16:creationId xmlns:a16="http://schemas.microsoft.com/office/drawing/2014/main" id="{DACBB61E-FC72-472D-B1DA-1E12FC964589}"/>
+                <a16:creationId xmlns:a16="http://schemas.microsoft.com/office/drawing/2014/main" id="{5E79631A-726A-4C72-9694-268501A59158}"/>
               </a:ext>
             </a:extLst>
           </p:cNvPr>
@@ -5968,7 +5968,7 @@
           <p:cNvPr id="5" name="">
             <a:extLst xmlns:a="http://schemas.openxmlformats.org/drawingml/2006/main">
               <a:ext uri="{FF2B5EF4-FFF2-40B4-BE49-F238E27FC236}">
-                <a16:creationId xmlns:a16="http://schemas.microsoft.com/office/drawing/2014/main" id="{068DBFFE-853B-461F-AD62-793C25B9A9E7}"/>
+                <a16:creationId xmlns:a16="http://schemas.microsoft.com/office/drawing/2014/main" id="{806814BA-9488-4C10-98B1-5257E5F04FB4}"/>
               </a:ext>
             </a:extLst>
           </p:cNvPr>
@@ -6030,7 +6030,7 @@
           <p:cNvPr id="6" name="">
             <a:extLst xmlns:a="http://schemas.openxmlformats.org/drawingml/2006/main">
               <a:ext uri="{FF2B5EF4-FFF2-40B4-BE49-F238E27FC236}">
-                <a16:creationId xmlns:a16="http://schemas.microsoft.com/office/drawing/2014/main" id="{63F7A9B2-5FBB-44E7-905E-CBF3E7ECD593}"/>
+                <a16:creationId xmlns:a16="http://schemas.microsoft.com/office/drawing/2014/main" id="{0F17ED27-A2B4-468E-AD3B-206E1ACD9915}"/>
               </a:ext>
             </a:extLst>
           </p:cNvPr>
@@ -6092,7 +6092,7 @@
           <p:cNvPr id="7" name="">
             <a:extLst xmlns:a="http://schemas.openxmlformats.org/drawingml/2006/main">
               <a:ext uri="{FF2B5EF4-FFF2-40B4-BE49-F238E27FC236}">
-                <a16:creationId xmlns:a16="http://schemas.microsoft.com/office/drawing/2014/main" id="{A4B6FB7B-F5B1-4A52-952A-D535CEA839D7}"/>
+                <a16:creationId xmlns:a16="http://schemas.microsoft.com/office/drawing/2014/main" id="{80F60C93-4842-498B-A920-059882BF2719}"/>
               </a:ext>
             </a:extLst>
           </p:cNvPr>
@@ -6123,7 +6123,7 @@
           <p:cNvPr id="8" name="">
             <a:extLst xmlns:a="http://schemas.openxmlformats.org/drawingml/2006/main">
               <a:ext uri="{FF2B5EF4-FFF2-40B4-BE49-F238E27FC236}">
-                <a16:creationId xmlns:a16="http://schemas.microsoft.com/office/drawing/2014/main" id="{FF43558C-05E2-490E-9A2A-838CEC3D2902}"/>
+                <a16:creationId xmlns:a16="http://schemas.microsoft.com/office/drawing/2014/main" id="{6D8E6502-6C07-40BB-B81B-0BB602C4101C}"/>
               </a:ext>
             </a:extLst>
           </p:cNvPr>
@@ -6185,7 +6185,7 @@
           <p:cNvPr id="9" name="">
             <a:extLst xmlns:a="http://schemas.openxmlformats.org/drawingml/2006/main">
               <a:ext uri="{FF2B5EF4-FFF2-40B4-BE49-F238E27FC236}">
-                <a16:creationId xmlns:a16="http://schemas.microsoft.com/office/drawing/2014/main" id="{D13548CE-A80B-44C0-B021-2E5A20C2F20D}"/>
+                <a16:creationId xmlns:a16="http://schemas.microsoft.com/office/drawing/2014/main" id="{B14E601A-19DA-4089-B9B8-22248A5542B7}"/>
               </a:ext>
             </a:extLst>
           </p:cNvPr>
@@ -6247,7 +6247,7 @@
           <p:cNvPr id="10" name="">
             <a:extLst xmlns:a="http://schemas.openxmlformats.org/drawingml/2006/main">
               <a:ext uri="{FF2B5EF4-FFF2-40B4-BE49-F238E27FC236}">
-                <a16:creationId xmlns:a16="http://schemas.microsoft.com/office/drawing/2014/main" id="{1E8BEECA-5C36-48BC-B488-20B463F5C8B5}"/>
+                <a16:creationId xmlns:a16="http://schemas.microsoft.com/office/drawing/2014/main" id="{DF306088-1A42-42B7-B897-B1DB77509CA8}"/>
               </a:ext>
             </a:extLst>
           </p:cNvPr>
@@ -6278,7 +6278,7 @@
           <p:cNvPr id="11" name="">
             <a:extLst xmlns:a="http://schemas.openxmlformats.org/drawingml/2006/main">
               <a:ext uri="{FF2B5EF4-FFF2-40B4-BE49-F238E27FC236}">
-                <a16:creationId xmlns:a16="http://schemas.microsoft.com/office/drawing/2014/main" id="{F05E5BC1-788F-4519-853E-9C043E1BE9B7}"/>
+                <a16:creationId xmlns:a16="http://schemas.microsoft.com/office/drawing/2014/main" id="{5146D2FF-B7E0-41EE-BDFD-8F432B6037C8}"/>
               </a:ext>
             </a:extLst>
           </p:cNvPr>
@@ -6340,7 +6340,7 @@
           <p:cNvPr id="12" name="">
             <a:extLst xmlns:a="http://schemas.openxmlformats.org/drawingml/2006/main">
               <a:ext uri="{FF2B5EF4-FFF2-40B4-BE49-F238E27FC236}">
-                <a16:creationId xmlns:a16="http://schemas.microsoft.com/office/drawing/2014/main" id="{4407412C-67DB-4F26-8DD9-21629776A4A5}"/>
+                <a16:creationId xmlns:a16="http://schemas.microsoft.com/office/drawing/2014/main" id="{ADE05F83-F5F0-4504-964B-2AABF0F38A5A}"/>
               </a:ext>
             </a:extLst>
           </p:cNvPr>
@@ -6402,7 +6402,7 @@
           <p:cNvPr id="13" name="">
             <a:extLst xmlns:a="http://schemas.openxmlformats.org/drawingml/2006/main">
               <a:ext uri="{FF2B5EF4-FFF2-40B4-BE49-F238E27FC236}">
-                <a16:creationId xmlns:a16="http://schemas.microsoft.com/office/drawing/2014/main" id="{23FEE5DC-E8F5-46EB-B2CF-CB9B49C1FCD1}"/>
+                <a16:creationId xmlns:a16="http://schemas.microsoft.com/office/drawing/2014/main" id="{FA94A69E-511C-48E4-9423-D82CB82FB262}"/>
               </a:ext>
             </a:extLst>
           </p:cNvPr>
@@ -6433,7 +6433,7 @@
           <p:cNvPr id="14" name="">
             <a:extLst xmlns:a="http://schemas.openxmlformats.org/drawingml/2006/main">
               <a:ext uri="{FF2B5EF4-FFF2-40B4-BE49-F238E27FC236}">
-                <a16:creationId xmlns:a16="http://schemas.microsoft.com/office/drawing/2014/main" id="{04F31E10-CA51-4483-97E0-F50A3A34F057}"/>
+                <a16:creationId xmlns:a16="http://schemas.microsoft.com/office/drawing/2014/main" id="{3A5EEEBC-59DA-48D0-9BDA-AA7DD4B390C2}"/>
               </a:ext>
             </a:extLst>
           </p:cNvPr>
@@ -6495,7 +6495,7 @@
           <p:cNvPr id="15" name="">
             <a:extLst xmlns:a="http://schemas.openxmlformats.org/drawingml/2006/main">
               <a:ext uri="{FF2B5EF4-FFF2-40B4-BE49-F238E27FC236}">
-                <a16:creationId xmlns:a16="http://schemas.microsoft.com/office/drawing/2014/main" id="{89DA5E28-5083-4FC6-BC71-14B56C788253}"/>
+                <a16:creationId xmlns:a16="http://schemas.microsoft.com/office/drawing/2014/main" id="{7C8D04F1-5824-4D17-BDB3-562B3E1FA94D}"/>
               </a:ext>
             </a:extLst>
           </p:cNvPr>
@@ -6557,7 +6557,7 @@
           <p:cNvPr id="16" name="">
             <a:extLst xmlns:a="http://schemas.openxmlformats.org/drawingml/2006/main">
               <a:ext uri="{FF2B5EF4-FFF2-40B4-BE49-F238E27FC236}">
-                <a16:creationId xmlns:a16="http://schemas.microsoft.com/office/drawing/2014/main" id="{C6B7C504-9B53-47B2-A0DE-8E70B21B45A6}"/>
+                <a16:creationId xmlns:a16="http://schemas.microsoft.com/office/drawing/2014/main" id="{BE159E2E-4E48-440F-AC07-3FF774FE221E}"/>
               </a:ext>
             </a:extLst>
           </p:cNvPr>
@@ -6588,7 +6588,7 @@
           <p:cNvPr id="17" name="">
             <a:extLst xmlns:a="http://schemas.openxmlformats.org/drawingml/2006/main">
               <a:ext uri="{FF2B5EF4-FFF2-40B4-BE49-F238E27FC236}">
-                <a16:creationId xmlns:a16="http://schemas.microsoft.com/office/drawing/2014/main" id="{EB8A8D05-B821-4FFC-BC8A-C7070C81A970}"/>
+                <a16:creationId xmlns:a16="http://schemas.microsoft.com/office/drawing/2014/main" id="{CED380D4-16EF-4728-9155-A1F3E80AC2A7}"/>
               </a:ext>
             </a:extLst>
           </p:cNvPr>
@@ -6648,7 +6648,7 @@
     </p:spTree>
     <p:extLst>
       <p:ext uri="{BB962C8B-B14F-4D97-AF65-F5344CB8AC3E}">
-        <p14:creationId xmlns:p14="http://schemas.microsoft.com/office/powerpoint/2010/main" val="293352321"/>
+        <p14:creationId xmlns:p14="http://schemas.microsoft.com/office/powerpoint/2010/main" val="238894881"/>
       </p:ext>
     </p:extLst>
   </p:cSld>
@@ -6679,7 +6679,7 @@
           <p:cNvPr id="7" name="">
             <a:extLst xmlns:a="http://schemas.openxmlformats.org/drawingml/2006/main">
               <a:ext uri="{FF2B5EF4-FFF2-40B4-BE49-F238E27FC236}">
-                <a16:creationId xmlns:a16="http://schemas.microsoft.com/office/drawing/2014/main" id="{9758A3E1-4C6A-4407-AB0C-659E79E0CDD4}"/>
+                <a16:creationId xmlns:a16="http://schemas.microsoft.com/office/drawing/2014/main" id="{16C57BE3-9B69-4922-9372-0A23D5F762AD}"/>
               </a:ext>
             </a:extLst>
           </p:cNvPr>
@@ -6741,7 +6741,7 @@
           <p:cNvPr id="2" name="">
             <a:extLst xmlns:a="http://schemas.openxmlformats.org/drawingml/2006/main">
               <a:ext uri="{FF2B5EF4-FFF2-40B4-BE49-F238E27FC236}">
-                <a16:creationId xmlns:a16="http://schemas.microsoft.com/office/drawing/2014/main" id="{D1C57E1D-0B79-46C7-8EBD-4AB22EC6384A}"/>
+                <a16:creationId xmlns:a16="http://schemas.microsoft.com/office/drawing/2014/main" id="{F5AF460A-F1C9-4119-B1BD-808511912941}"/>
               </a:ext>
             </a:extLst>
           </p:cNvPr>
@@ -6803,7 +6803,7 @@
           <p:cNvPr id="3" name="">
             <a:extLst xmlns:a="http://schemas.openxmlformats.org/drawingml/2006/main">
               <a:ext uri="{FF2B5EF4-FFF2-40B4-BE49-F238E27FC236}">
-                <a16:creationId xmlns:a16="http://schemas.microsoft.com/office/drawing/2014/main" id="{4C501DE6-173E-435D-84AA-BDFF50B2DBDF}"/>
+                <a16:creationId xmlns:a16="http://schemas.microsoft.com/office/drawing/2014/main" id="{504BC109-BAE7-4959-A95B-8F19CA389B7F}"/>
               </a:ext>
             </a:extLst>
           </p:cNvPr>
@@ -6865,7 +6865,7 @@
           <p:cNvPr id="4" name="">
             <a:extLst xmlns:a="http://schemas.openxmlformats.org/drawingml/2006/main">
               <a:ext uri="{FF2B5EF4-FFF2-40B4-BE49-F238E27FC236}">
-                <a16:creationId xmlns:a16="http://schemas.microsoft.com/office/drawing/2014/main" id="{470536E1-073F-49CE-BE35-376724380F83}"/>
+                <a16:creationId xmlns:a16="http://schemas.microsoft.com/office/drawing/2014/main" id="{B19868C3-C697-4BA7-B6A9-656E0FC0151E}"/>
               </a:ext>
             </a:extLst>
           </p:cNvPr>
@@ -6896,7 +6896,7 @@
           <p:cNvPr id="5" name="">
             <a:extLst xmlns:a="http://schemas.openxmlformats.org/drawingml/2006/main">
               <a:ext uri="{FF2B5EF4-FFF2-40B4-BE49-F238E27FC236}">
-                <a16:creationId xmlns:a16="http://schemas.microsoft.com/office/drawing/2014/main" id="{AC298578-7885-4360-AF5D-3F040A8DA1FD}"/>
+                <a16:creationId xmlns:a16="http://schemas.microsoft.com/office/drawing/2014/main" id="{CFAB80A3-AB73-4AF3-9C73-CACBD94602E3}"/>
               </a:ext>
             </a:extLst>
           </p:cNvPr>
@@ -7248,7 +7248,7 @@
     </p:spTree>
     <p:extLst>
       <p:ext uri="{BB962C8B-B14F-4D97-AF65-F5344CB8AC3E}">
-        <p14:creationId xmlns:p14="http://schemas.microsoft.com/office/powerpoint/2010/main" val="379572655"/>
+        <p14:creationId xmlns:p14="http://schemas.microsoft.com/office/powerpoint/2010/main" val="1363024967"/>
       </p:ext>
     </p:extLst>
   </p:cSld>
@@ -7279,7 +7279,7 @@
           <p:cNvPr id="18" name="">
             <a:extLst xmlns:a="http://schemas.openxmlformats.org/drawingml/2006/main">
               <a:ext uri="{FF2B5EF4-FFF2-40B4-BE49-F238E27FC236}">
-                <a16:creationId xmlns:a16="http://schemas.microsoft.com/office/drawing/2014/main" id="{7E18801D-6B14-42AB-B596-30C1F7F65D52}"/>
+                <a16:creationId xmlns:a16="http://schemas.microsoft.com/office/drawing/2014/main" id="{A5FCEBFB-FBF5-4D37-9943-3D74DFAB48F1}"/>
               </a:ext>
             </a:extLst>
           </p:cNvPr>
@@ -7341,7 +7341,7 @@
           <p:cNvPr id="2" name="">
             <a:extLst xmlns:a="http://schemas.openxmlformats.org/drawingml/2006/main">
               <a:ext uri="{FF2B5EF4-FFF2-40B4-BE49-F238E27FC236}">
-                <a16:creationId xmlns:a16="http://schemas.microsoft.com/office/drawing/2014/main" id="{149DE239-4310-4DC0-8FA4-AE92976B3FF6}"/>
+                <a16:creationId xmlns:a16="http://schemas.microsoft.com/office/drawing/2014/main" id="{BBA39CE1-3A8A-4306-9981-36E0F3D46913}"/>
               </a:ext>
             </a:extLst>
           </p:cNvPr>
@@ -7403,7 +7403,7 @@
           <p:cNvPr id="3" name="">
             <a:extLst xmlns:a="http://schemas.openxmlformats.org/drawingml/2006/main">
               <a:ext uri="{FF2B5EF4-FFF2-40B4-BE49-F238E27FC236}">
-                <a16:creationId xmlns:a16="http://schemas.microsoft.com/office/drawing/2014/main" id="{91FDCB07-4E15-405D-8837-1A87794A8708}"/>
+                <a16:creationId xmlns:a16="http://schemas.microsoft.com/office/drawing/2014/main" id="{A2D0D863-C86B-45C1-9A3C-B8090247DD06}"/>
               </a:ext>
             </a:extLst>
           </p:cNvPr>
@@ -7465,7 +7465,7 @@
           <p:cNvPr id="4" name="">
             <a:extLst xmlns:a="http://schemas.openxmlformats.org/drawingml/2006/main">
               <a:ext uri="{FF2B5EF4-FFF2-40B4-BE49-F238E27FC236}">
-                <a16:creationId xmlns:a16="http://schemas.microsoft.com/office/drawing/2014/main" id="{61AD0FF6-1868-40CD-B943-490CE793C5D8}"/>
+                <a16:creationId xmlns:a16="http://schemas.microsoft.com/office/drawing/2014/main" id="{DC6740AA-9441-4767-ADDA-D39D8A8C662B}"/>
               </a:ext>
             </a:extLst>
           </p:cNvPr>
@@ -7496,7 +7496,7 @@
           <p:cNvPr id="5" name="">
             <a:extLst xmlns:a="http://schemas.openxmlformats.org/drawingml/2006/main">
               <a:ext uri="{FF2B5EF4-FFF2-40B4-BE49-F238E27FC236}">
-                <a16:creationId xmlns:a16="http://schemas.microsoft.com/office/drawing/2014/main" id="{D0D0E67B-7925-490F-9792-EC12287A84EE}"/>
+                <a16:creationId xmlns:a16="http://schemas.microsoft.com/office/drawing/2014/main" id="{423C5E48-6BF3-4A48-8F93-CCFCC0346715}"/>
               </a:ext>
             </a:extLst>
           </p:cNvPr>
@@ -7558,7 +7558,7 @@
           <p:cNvPr id="6" name="">
             <a:extLst xmlns:a="http://schemas.openxmlformats.org/drawingml/2006/main">
               <a:ext uri="{FF2B5EF4-FFF2-40B4-BE49-F238E27FC236}">
-                <a16:creationId xmlns:a16="http://schemas.microsoft.com/office/drawing/2014/main" id="{AC5B3949-EBA3-4DE9-AA75-D64692D7675F}"/>
+                <a16:creationId xmlns:a16="http://schemas.microsoft.com/office/drawing/2014/main" id="{C33063AB-7AD2-432D-BE8F-B85FF8009839}"/>
               </a:ext>
             </a:extLst>
           </p:cNvPr>
@@ -7620,7 +7620,7 @@
           <p:cNvPr id="7" name="">
             <a:extLst xmlns:a="http://schemas.openxmlformats.org/drawingml/2006/main">
               <a:ext uri="{FF2B5EF4-FFF2-40B4-BE49-F238E27FC236}">
-                <a16:creationId xmlns:a16="http://schemas.microsoft.com/office/drawing/2014/main" id="{D6BE321A-48DB-4BEE-BC8B-C3BB027F633D}"/>
+                <a16:creationId xmlns:a16="http://schemas.microsoft.com/office/drawing/2014/main" id="{74A46DCF-DF69-46DE-A977-91EB5C807003}"/>
               </a:ext>
             </a:extLst>
           </p:cNvPr>
@@ -7682,7 +7682,7 @@
           <p:cNvPr id="8" name="">
             <a:extLst xmlns:a="http://schemas.openxmlformats.org/drawingml/2006/main">
               <a:ext uri="{FF2B5EF4-FFF2-40B4-BE49-F238E27FC236}">
-                <a16:creationId xmlns:a16="http://schemas.microsoft.com/office/drawing/2014/main" id="{15328B2E-9F33-4563-B752-F129053D206C}"/>
+                <a16:creationId xmlns:a16="http://schemas.microsoft.com/office/drawing/2014/main" id="{6F18A23A-24C8-41F8-9401-B78279D5F738}"/>
               </a:ext>
             </a:extLst>
           </p:cNvPr>
@@ -7744,7 +7744,7 @@
           <p:cNvPr id="9" name="">
             <a:extLst xmlns:a="http://schemas.openxmlformats.org/drawingml/2006/main">
               <a:ext uri="{FF2B5EF4-FFF2-40B4-BE49-F238E27FC236}">
-                <a16:creationId xmlns:a16="http://schemas.microsoft.com/office/drawing/2014/main" id="{E44398AB-1F1C-457F-B421-84DD5B135BFA}"/>
+                <a16:creationId xmlns:a16="http://schemas.microsoft.com/office/drawing/2014/main" id="{034F2B7F-FAED-4456-9899-6F4F2FFD6A80}"/>
               </a:ext>
             </a:extLst>
           </p:cNvPr>
@@ -7775,7 +7775,7 @@
           <p:cNvPr id="10" name="">
             <a:extLst xmlns:a="http://schemas.openxmlformats.org/drawingml/2006/main">
               <a:ext uri="{FF2B5EF4-FFF2-40B4-BE49-F238E27FC236}">
-                <a16:creationId xmlns:a16="http://schemas.microsoft.com/office/drawing/2014/main" id="{EE867691-E594-4419-ACC5-CE1223462B25}"/>
+                <a16:creationId xmlns:a16="http://schemas.microsoft.com/office/drawing/2014/main" id="{82B7B6A3-3796-48DF-9766-1D87363E365F}"/>
               </a:ext>
             </a:extLst>
           </p:cNvPr>
@@ -7837,7 +7837,7 @@
           <p:cNvPr id="11" name="">
             <a:extLst xmlns:a="http://schemas.openxmlformats.org/drawingml/2006/main">
               <a:ext uri="{FF2B5EF4-FFF2-40B4-BE49-F238E27FC236}">
-                <a16:creationId xmlns:a16="http://schemas.microsoft.com/office/drawing/2014/main" id="{ADA3D4E1-E562-4BBC-942A-5514257EAAAC}"/>
+                <a16:creationId xmlns:a16="http://schemas.microsoft.com/office/drawing/2014/main" id="{9FED4E0C-7B79-4AB2-8A6E-49EA7DD360AE}"/>
               </a:ext>
             </a:extLst>
           </p:cNvPr>
@@ -7899,7 +7899,7 @@
           <p:cNvPr id="12" name="">
             <a:extLst xmlns:a="http://schemas.openxmlformats.org/drawingml/2006/main">
               <a:ext uri="{FF2B5EF4-FFF2-40B4-BE49-F238E27FC236}">
-                <a16:creationId xmlns:a16="http://schemas.microsoft.com/office/drawing/2014/main" id="{F25DBB20-56E6-44DD-A8D0-90C76DC3331D}"/>
+                <a16:creationId xmlns:a16="http://schemas.microsoft.com/office/drawing/2014/main" id="{9598C835-E6D7-4EA9-87BD-98E4F2B8B9F7}"/>
               </a:ext>
             </a:extLst>
           </p:cNvPr>
@@ -7961,7 +7961,7 @@
           <p:cNvPr id="13" name="">
             <a:extLst xmlns:a="http://schemas.openxmlformats.org/drawingml/2006/main">
               <a:ext uri="{FF2B5EF4-FFF2-40B4-BE49-F238E27FC236}">
-                <a16:creationId xmlns:a16="http://schemas.microsoft.com/office/drawing/2014/main" id="{A52D6D46-1F7A-4B2E-86C8-83ACFE2CC721}"/>
+                <a16:creationId xmlns:a16="http://schemas.microsoft.com/office/drawing/2014/main" id="{D266E988-202B-45C2-AD02-A19A880DEC5D}"/>
               </a:ext>
             </a:extLst>
           </p:cNvPr>
@@ -7992,7 +7992,7 @@
           <p:cNvPr id="14" name="">
             <a:extLst xmlns:a="http://schemas.openxmlformats.org/drawingml/2006/main">
               <a:ext uri="{FF2B5EF4-FFF2-40B4-BE49-F238E27FC236}">
-                <a16:creationId xmlns:a16="http://schemas.microsoft.com/office/drawing/2014/main" id="{4D28BB4E-A6CD-48C3-BBA3-80C8B38F0621}"/>
+                <a16:creationId xmlns:a16="http://schemas.microsoft.com/office/drawing/2014/main" id="{330496DD-0F47-402F-8918-563CF944499A}"/>
               </a:ext>
             </a:extLst>
           </p:cNvPr>
@@ -8054,7 +8054,7 @@
           <p:cNvPr id="15" name="">
             <a:extLst xmlns:a="http://schemas.openxmlformats.org/drawingml/2006/main">
               <a:ext uri="{FF2B5EF4-FFF2-40B4-BE49-F238E27FC236}">
-                <a16:creationId xmlns:a16="http://schemas.microsoft.com/office/drawing/2014/main" id="{EF515DF8-B46B-4178-8471-A9F63EB3A371}"/>
+                <a16:creationId xmlns:a16="http://schemas.microsoft.com/office/drawing/2014/main" id="{7056D34D-9C1D-4C22-96BB-4598B55F3409}"/>
               </a:ext>
             </a:extLst>
           </p:cNvPr>
@@ -8116,7 +8116,7 @@
           <p:cNvPr id="16" name="">
             <a:extLst xmlns:a="http://schemas.openxmlformats.org/drawingml/2006/main">
               <a:ext uri="{FF2B5EF4-FFF2-40B4-BE49-F238E27FC236}">
-                <a16:creationId xmlns:a16="http://schemas.microsoft.com/office/drawing/2014/main" id="{743CEC72-97AC-441A-BF6C-2D842FDC6FD0}"/>
+                <a16:creationId xmlns:a16="http://schemas.microsoft.com/office/drawing/2014/main" id="{CC3B6634-4134-4306-BE69-B2FCB3E7CD55}"/>
               </a:ext>
             </a:extLst>
           </p:cNvPr>
@@ -8178,7 +8178,7 @@
           <p:cNvPr id="17" name="">
             <a:extLst xmlns:a="http://schemas.openxmlformats.org/drawingml/2006/main">
               <a:ext uri="{FF2B5EF4-FFF2-40B4-BE49-F238E27FC236}">
-                <a16:creationId xmlns:a16="http://schemas.microsoft.com/office/drawing/2014/main" id="{292C086E-59ED-46DB-A142-0BFFE4707314}"/>
+                <a16:creationId xmlns:a16="http://schemas.microsoft.com/office/drawing/2014/main" id="{C22C3C38-3742-491D-968B-6170DFF36E95}"/>
               </a:ext>
             </a:extLst>
           </p:cNvPr>
@@ -8207,7 +8207,7 @@
     </p:spTree>
     <p:extLst>
       <p:ext uri="{BB962C8B-B14F-4D97-AF65-F5344CB8AC3E}">
-        <p14:creationId xmlns:p14="http://schemas.microsoft.com/office/powerpoint/2010/main" val="1882868462"/>
+        <p14:creationId xmlns:p14="http://schemas.microsoft.com/office/powerpoint/2010/main" val="2020806733"/>
       </p:ext>
     </p:extLst>
   </p:cSld>
@@ -8238,7 +8238,7 @@
           <p:cNvPr id="18" name="">
             <a:extLst xmlns:a="http://schemas.openxmlformats.org/drawingml/2006/main">
               <a:ext uri="{FF2B5EF4-FFF2-40B4-BE49-F238E27FC236}">
-                <a16:creationId xmlns:a16="http://schemas.microsoft.com/office/drawing/2014/main" id="{50C07D4D-A97E-4128-A015-845B4BC51B75}"/>
+                <a16:creationId xmlns:a16="http://schemas.microsoft.com/office/drawing/2014/main" id="{8EF54AB1-F8C7-4EDD-B378-078E9153D90A}"/>
               </a:ext>
             </a:extLst>
           </p:cNvPr>
@@ -8300,7 +8300,7 @@
           <p:cNvPr id="2" name="">
             <a:extLst xmlns:a="http://schemas.openxmlformats.org/drawingml/2006/main">
               <a:ext uri="{FF2B5EF4-FFF2-40B4-BE49-F238E27FC236}">
-                <a16:creationId xmlns:a16="http://schemas.microsoft.com/office/drawing/2014/main" id="{277A7DE5-C369-4F21-9A60-19657B74A39B}"/>
+                <a16:creationId xmlns:a16="http://schemas.microsoft.com/office/drawing/2014/main" id="{302A7C64-5EAC-4AE6-9F14-703BD2BDEEB4}"/>
               </a:ext>
             </a:extLst>
           </p:cNvPr>
@@ -8362,7 +8362,7 @@
           <p:cNvPr id="3" name="">
             <a:extLst xmlns:a="http://schemas.openxmlformats.org/drawingml/2006/main">
               <a:ext uri="{FF2B5EF4-FFF2-40B4-BE49-F238E27FC236}">
-                <a16:creationId xmlns:a16="http://schemas.microsoft.com/office/drawing/2014/main" id="{FBA22B08-C56D-4D6F-8C66-3694A64CB1C0}"/>
+                <a16:creationId xmlns:a16="http://schemas.microsoft.com/office/drawing/2014/main" id="{68BC218E-49BE-43E8-8D87-EAE3AFAEE69C}"/>
               </a:ext>
             </a:extLst>
           </p:cNvPr>
@@ -8424,7 +8424,7 @@
           <p:cNvPr id="4" name="">
             <a:extLst xmlns:a="http://schemas.openxmlformats.org/drawingml/2006/main">
               <a:ext uri="{FF2B5EF4-FFF2-40B4-BE49-F238E27FC236}">
-                <a16:creationId xmlns:a16="http://schemas.microsoft.com/office/drawing/2014/main" id="{0E3B2957-94EB-4219-9ACA-B7C002484D93}"/>
+                <a16:creationId xmlns:a16="http://schemas.microsoft.com/office/drawing/2014/main" id="{764E504D-7CC1-4C1E-9984-E5F9A8A7AD4D}"/>
               </a:ext>
             </a:extLst>
           </p:cNvPr>
@@ -8455,7 +8455,7 @@
           <p:cNvPr id="5" name="">
             <a:extLst xmlns:a="http://schemas.openxmlformats.org/drawingml/2006/main">
               <a:ext uri="{FF2B5EF4-FFF2-40B4-BE49-F238E27FC236}">
-                <a16:creationId xmlns:a16="http://schemas.microsoft.com/office/drawing/2014/main" id="{4533D06B-2FF4-407D-9A8B-A2595EE6D7A4}"/>
+                <a16:creationId xmlns:a16="http://schemas.microsoft.com/office/drawing/2014/main" id="{C077FAEA-E965-4277-B9E7-6BF397E27CC4}"/>
               </a:ext>
             </a:extLst>
           </p:cNvPr>
@@ -8517,7 +8517,7 @@
           <p:cNvPr id="6" name="">
             <a:extLst xmlns:a="http://schemas.openxmlformats.org/drawingml/2006/main">
               <a:ext uri="{FF2B5EF4-FFF2-40B4-BE49-F238E27FC236}">
-                <a16:creationId xmlns:a16="http://schemas.microsoft.com/office/drawing/2014/main" id="{EF59484A-9628-456E-BDDD-F0A71E086B76}"/>
+                <a16:creationId xmlns:a16="http://schemas.microsoft.com/office/drawing/2014/main" id="{0CDE9A88-8046-4B5C-8D46-56299DE1F4A2}"/>
               </a:ext>
             </a:extLst>
           </p:cNvPr>
@@ -8579,7 +8579,7 @@
           <p:cNvPr id="7" name="">
             <a:extLst xmlns:a="http://schemas.openxmlformats.org/drawingml/2006/main">
               <a:ext uri="{FF2B5EF4-FFF2-40B4-BE49-F238E27FC236}">
-                <a16:creationId xmlns:a16="http://schemas.microsoft.com/office/drawing/2014/main" id="{76D143D1-C3C3-472E-8F14-A9CB16041290}"/>
+                <a16:creationId xmlns:a16="http://schemas.microsoft.com/office/drawing/2014/main" id="{C0A93B5D-EC62-4012-A76C-3CBB1F0E5CA9}"/>
               </a:ext>
             </a:extLst>
           </p:cNvPr>
@@ -8641,7 +8641,7 @@
           <p:cNvPr id="8" name="">
             <a:extLst xmlns:a="http://schemas.openxmlformats.org/drawingml/2006/main">
               <a:ext uri="{FF2B5EF4-FFF2-40B4-BE49-F238E27FC236}">
-                <a16:creationId xmlns:a16="http://schemas.microsoft.com/office/drawing/2014/main" id="{EE04869B-098A-41C1-8EB7-D9D26BAACF60}"/>
+                <a16:creationId xmlns:a16="http://schemas.microsoft.com/office/drawing/2014/main" id="{ED2465AB-0460-41B0-BF01-16DB607A4F05}"/>
               </a:ext>
             </a:extLst>
           </p:cNvPr>
@@ -8703,7 +8703,7 @@
           <p:cNvPr id="9" name="">
             <a:extLst xmlns:a="http://schemas.openxmlformats.org/drawingml/2006/main">
               <a:ext uri="{FF2B5EF4-FFF2-40B4-BE49-F238E27FC236}">
-                <a16:creationId xmlns:a16="http://schemas.microsoft.com/office/drawing/2014/main" id="{E1FBBB57-7C0D-420C-B008-18C4170F9CCA}"/>
+                <a16:creationId xmlns:a16="http://schemas.microsoft.com/office/drawing/2014/main" id="{A632FB5B-3763-4B63-93FB-B46481FD6BE1}"/>
               </a:ext>
             </a:extLst>
           </p:cNvPr>
@@ -8734,7 +8734,7 @@
           <p:cNvPr id="10" name="">
             <a:extLst xmlns:a="http://schemas.openxmlformats.org/drawingml/2006/main">
               <a:ext uri="{FF2B5EF4-FFF2-40B4-BE49-F238E27FC236}">
-                <a16:creationId xmlns:a16="http://schemas.microsoft.com/office/drawing/2014/main" id="{EF344504-5FD8-4E3F-8F49-8636378E2177}"/>
+                <a16:creationId xmlns:a16="http://schemas.microsoft.com/office/drawing/2014/main" id="{2DEB5EA9-3C18-4683-A0F2-DB65E518509B}"/>
               </a:ext>
             </a:extLst>
           </p:cNvPr>
@@ -8796,7 +8796,7 @@
           <p:cNvPr id="11" name="">
             <a:extLst xmlns:a="http://schemas.openxmlformats.org/drawingml/2006/main">
               <a:ext uri="{FF2B5EF4-FFF2-40B4-BE49-F238E27FC236}">
-                <a16:creationId xmlns:a16="http://schemas.microsoft.com/office/drawing/2014/main" id="{22047CFC-0D91-4863-B116-4B056C3055AC}"/>
+                <a16:creationId xmlns:a16="http://schemas.microsoft.com/office/drawing/2014/main" id="{CFC1A943-7DD0-4B78-BA30-49E93E354131}"/>
               </a:ext>
             </a:extLst>
           </p:cNvPr>
@@ -8858,7 +8858,7 @@
           <p:cNvPr id="12" name="">
             <a:extLst xmlns:a="http://schemas.openxmlformats.org/drawingml/2006/main">
               <a:ext uri="{FF2B5EF4-FFF2-40B4-BE49-F238E27FC236}">
-                <a16:creationId xmlns:a16="http://schemas.microsoft.com/office/drawing/2014/main" id="{101F05D3-08B3-4D2E-8767-E699E7F2A2F4}"/>
+                <a16:creationId xmlns:a16="http://schemas.microsoft.com/office/drawing/2014/main" id="{F8DA7B25-795E-4E9D-98F4-7718A77B430B}"/>
               </a:ext>
             </a:extLst>
           </p:cNvPr>
@@ -8920,7 +8920,7 @@
           <p:cNvPr id="13" name="">
             <a:extLst xmlns:a="http://schemas.openxmlformats.org/drawingml/2006/main">
               <a:ext uri="{FF2B5EF4-FFF2-40B4-BE49-F238E27FC236}">
-                <a16:creationId xmlns:a16="http://schemas.microsoft.com/office/drawing/2014/main" id="{3A32C803-67D6-409C-94AB-6C73BE4063D2}"/>
+                <a16:creationId xmlns:a16="http://schemas.microsoft.com/office/drawing/2014/main" id="{C20A2E49-BA49-4CA6-A094-4E6DCA430BDD}"/>
               </a:ext>
             </a:extLst>
           </p:cNvPr>
@@ -8951,7 +8951,7 @@
           <p:cNvPr id="14" name="">
             <a:extLst xmlns:a="http://schemas.openxmlformats.org/drawingml/2006/main">
               <a:ext uri="{FF2B5EF4-FFF2-40B4-BE49-F238E27FC236}">
-                <a16:creationId xmlns:a16="http://schemas.microsoft.com/office/drawing/2014/main" id="{8488F714-14AD-434D-836F-B27683CC9C49}"/>
+                <a16:creationId xmlns:a16="http://schemas.microsoft.com/office/drawing/2014/main" id="{C7E12994-BCF9-483F-B620-68BE4BFDC07F}"/>
               </a:ext>
             </a:extLst>
           </p:cNvPr>
@@ -9013,7 +9013,7 @@
           <p:cNvPr id="15" name="">
             <a:extLst xmlns:a="http://schemas.openxmlformats.org/drawingml/2006/main">
               <a:ext uri="{FF2B5EF4-FFF2-40B4-BE49-F238E27FC236}">
-                <a16:creationId xmlns:a16="http://schemas.microsoft.com/office/drawing/2014/main" id="{F013E8E0-5D46-41D9-93B4-77CD7400AFDA}"/>
+                <a16:creationId xmlns:a16="http://schemas.microsoft.com/office/drawing/2014/main" id="{CD71EE98-0B0A-48C3-A394-E44B51DA5C74}"/>
               </a:ext>
             </a:extLst>
           </p:cNvPr>
@@ -9075,7 +9075,7 @@
           <p:cNvPr id="16" name="">
             <a:extLst xmlns:a="http://schemas.openxmlformats.org/drawingml/2006/main">
               <a:ext uri="{FF2B5EF4-FFF2-40B4-BE49-F238E27FC236}">
-                <a16:creationId xmlns:a16="http://schemas.microsoft.com/office/drawing/2014/main" id="{1539CD36-8F0A-4CB7-8DE1-C67D26C0587B}"/>
+                <a16:creationId xmlns:a16="http://schemas.microsoft.com/office/drawing/2014/main" id="{262C73A6-FFAC-489F-8F3D-015DBDE00ADE}"/>
               </a:ext>
             </a:extLst>
           </p:cNvPr>
@@ -9137,7 +9137,7 @@
           <p:cNvPr id="17" name="">
             <a:extLst xmlns:a="http://schemas.openxmlformats.org/drawingml/2006/main">
               <a:ext uri="{FF2B5EF4-FFF2-40B4-BE49-F238E27FC236}">
-                <a16:creationId xmlns:a16="http://schemas.microsoft.com/office/drawing/2014/main" id="{968DBD1C-BF14-4457-AF19-EBD16B55DDCB}"/>
+                <a16:creationId xmlns:a16="http://schemas.microsoft.com/office/drawing/2014/main" id="{A5D0D84E-EE0D-4375-A41D-3E4CDB1F8CAF}"/>
               </a:ext>
             </a:extLst>
           </p:cNvPr>
@@ -9166,7 +9166,7 @@
     </p:spTree>
     <p:extLst>
       <p:ext uri="{BB962C8B-B14F-4D97-AF65-F5344CB8AC3E}">
-        <p14:creationId xmlns:p14="http://schemas.microsoft.com/office/powerpoint/2010/main" val="2135655293"/>
+        <p14:creationId xmlns:p14="http://schemas.microsoft.com/office/powerpoint/2010/main" val="1630684197"/>
       </p:ext>
     </p:extLst>
   </p:cSld>
@@ -9197,7 +9197,7 @@
           <p:cNvPr id="7" name="">
             <a:extLst xmlns:a="http://schemas.openxmlformats.org/drawingml/2006/main">
               <a:ext uri="{FF2B5EF4-FFF2-40B4-BE49-F238E27FC236}">
-                <a16:creationId xmlns:a16="http://schemas.microsoft.com/office/drawing/2014/main" id="{3CDD2FAC-7D26-4F86-9936-55500BEE0BDE}"/>
+                <a16:creationId xmlns:a16="http://schemas.microsoft.com/office/drawing/2014/main" id="{DCB9F551-60B3-48A3-B6BC-FA0694DF2F5C}"/>
               </a:ext>
             </a:extLst>
           </p:cNvPr>
@@ -9259,7 +9259,7 @@
           <p:cNvPr id="2" name="">
             <a:extLst xmlns:a="http://schemas.openxmlformats.org/drawingml/2006/main">
               <a:ext uri="{FF2B5EF4-FFF2-40B4-BE49-F238E27FC236}">
-                <a16:creationId xmlns:a16="http://schemas.microsoft.com/office/drawing/2014/main" id="{E5858D13-5343-438D-BF65-48D251429BBB}"/>
+                <a16:creationId xmlns:a16="http://schemas.microsoft.com/office/drawing/2014/main" id="{3B28FA1D-253D-4583-B963-CD0618C04B22}"/>
               </a:ext>
             </a:extLst>
           </p:cNvPr>
@@ -9321,7 +9321,7 @@
           <p:cNvPr id="3" name="">
             <a:extLst xmlns:a="http://schemas.openxmlformats.org/drawingml/2006/main">
               <a:ext uri="{FF2B5EF4-FFF2-40B4-BE49-F238E27FC236}">
-                <a16:creationId xmlns:a16="http://schemas.microsoft.com/office/drawing/2014/main" id="{782FF272-9C0F-48F9-A03B-E685430CB90A}"/>
+                <a16:creationId xmlns:a16="http://schemas.microsoft.com/office/drawing/2014/main" id="{F678A5BC-C621-4405-A7F8-DA6FDE08DEE5}"/>
               </a:ext>
             </a:extLst>
           </p:cNvPr>
@@ -9383,7 +9383,7 @@
           <p:cNvPr id="4" name="">
             <a:extLst xmlns:a="http://schemas.openxmlformats.org/drawingml/2006/main">
               <a:ext uri="{FF2B5EF4-FFF2-40B4-BE49-F238E27FC236}">
-                <a16:creationId xmlns:a16="http://schemas.microsoft.com/office/drawing/2014/main" id="{26E8D2C4-EC3F-4D4E-9FE0-6D2AE0BC194B}"/>
+                <a16:creationId xmlns:a16="http://schemas.microsoft.com/office/drawing/2014/main" id="{1198B3BD-D8EC-4B64-806A-CF2DD21288C4}"/>
               </a:ext>
             </a:extLst>
           </p:cNvPr>
@@ -9414,7 +9414,7 @@
           <p:cNvPr id="5" name="">
             <a:extLst xmlns:a="http://schemas.openxmlformats.org/drawingml/2006/main">
               <a:ext uri="{FF2B5EF4-FFF2-40B4-BE49-F238E27FC236}">
-                <a16:creationId xmlns:a16="http://schemas.microsoft.com/office/drawing/2014/main" id="{775B4FE8-D032-4525-8A29-71F282B5CB89}"/>
+                <a16:creationId xmlns:a16="http://schemas.microsoft.com/office/drawing/2014/main" id="{366DCAA2-51AF-4F28-B193-34577EC583B5}"/>
               </a:ext>
             </a:extLst>
           </p:cNvPr>
@@ -9479,7 +9479,7 @@
         </p:nvGraphicFramePr>
         <p:xfrm>
           <a:off xmlns:a="http://schemas.openxmlformats.org/drawingml/2006/main" x="609600" y="1809750"/>
-          <a:ext xmlns:a="http://schemas.openxmlformats.org/drawingml/2006/main" cx="10972800" cy="2395220"/>
+          <a:ext xmlns:a="http://schemas.openxmlformats.org/drawingml/2006/main" cx="10972800" cy="2874264"/>
         </p:xfrm>
         <a:graphic xmlns:a="http://schemas.openxmlformats.org/drawingml/2006/main">
           <a:graphicData uri="http://schemas.openxmlformats.org/drawingml/2006/table">
@@ -9586,7 +9586,7 @@
                           <a:ea typeface="AppleGothic"/>
                           <a:cs typeface="AppleGothic"/>
                         </a:rPr>
-                        <a:t>2–4인 자율 팀 · 팀 지원 URL 등록 · LMS 제출</a:t>
+                        <a:t>2–4인 자율 팀 · 지원 URL · LMS 제출</a:t>
                       </a:r>
                     </a:p>
                   </a:txBody>
@@ -9640,7 +9640,7 @@
                           <a:ea typeface="AppleGothic"/>
                           <a:cs typeface="AppleGothic"/>
                         </a:rPr>
-                        <a:t>개인 기획서 · 이메일 제출</a:t>
+                        <a:t>개인 진행 가능 · 공지된 교수 이메일 제출</a:t>
                       </a:r>
                     </a:p>
                   </a:txBody>
@@ -9668,7 +9668,7 @@
                           <a:ea typeface="AppleGothic"/>
                           <a:cs typeface="AppleGothic"/>
                         </a:rPr>
-                        <a:t>공통</a:t>
+                        <a:t>7주차 · 10.16</a:t>
                       </a:r>
                     </a:p>
                   </a:txBody>
@@ -9694,7 +9694,61 @@
                           <a:ea typeface="AppleGothic"/>
                           <a:cs typeface="AppleGothic"/>
                         </a:rPr>
-                        <a:t>10.23 온라인 제출·평가 · 실시간 수업·중간고사 없음</a:t>
+                        <a:t>초안 먼저 제출 · 교수 피드백 후 수정</a:t>
+                      </a:r>
+                    </a:p>
+                  </a:txBody>
+                  <a:tcPr marL="91440" marR="91440" marT="45720" marB="45720" anchor="ctr">
+                    <a:solidFill>
+                      <a:srgbClr val="FFFFFF"/>
+                    </a:solidFill>
+                  </a:tcPr>
+                </a:tc>
+              </a:tr>
+              <a:tr h="479044">
+                <a:tc>
+                  <a:txBody>
+                    <a:bodyPr wrap="none" lIns="133350" tIns="114300" rIns="133350" bIns="114300">
+                      <a:noAutofit/>
+                    </a:bodyPr>
+                    <a:lstStyle/>
+                    <a:p>
+                      <a:r>
+                        <a:rPr sz="1700" b="0">
+                          <a:solidFill>
+                            <a:srgbClr val="151719"/>
+                          </a:solidFill>
+                          <a:latin typeface="AppleGothic"/>
+                          <a:ea typeface="AppleGothic"/>
+                          <a:cs typeface="AppleGothic"/>
+                        </a:rPr>
+                        <a:t>8주차 · 10.23</a:t>
+                      </a:r>
+                    </a:p>
+                  </a:txBody>
+                  <a:tcPr marL="91440" marR="91440" marT="45720" marB="45720" anchor="ctr">
+                    <a:solidFill>
+                      <a:srgbClr val="FFFFFF"/>
+                    </a:solidFill>
+                  </a:tcPr>
+                </a:tc>
+                <a:tc>
+                  <a:txBody>
+                    <a:bodyPr wrap="none" lIns="133350" tIns="114300" rIns="133350" bIns="114300">
+                      <a:noAutofit/>
+                    </a:bodyPr>
+                    <a:lstStyle/>
+                    <a:p>
+                      <a:r>
+                        <a:rPr sz="1700" b="0">
+                          <a:solidFill>
+                            <a:srgbClr val="151719"/>
+                          </a:solidFill>
+                          <a:latin typeface="AppleGothic"/>
+                          <a:ea typeface="AppleGothic"/>
+                          <a:cs typeface="AppleGothic"/>
+                        </a:rPr>
+                        <a:t>수정본 온라인 제출·평가 · 시험 없음</a:t>
                       </a:r>
                     </a:p>
                   </a:txBody>
@@ -9748,7 +9802,7 @@
                           <a:ea typeface="AppleGothic"/>
                           <a:cs typeface="AppleGothic"/>
                         </a:rPr>
-                        <a:t>HTML·Word·PDF·PPT 자유 · 열리는 링크·파일 확인</a:t>
+                        <a:t>PPT·Word·PDF·HTML 가능 · 한글(HWP) 제외</a:t>
                       </a:r>
                     </a:p>
                   </a:txBody>
@@ -9766,7 +9820,7 @@
     </p:spTree>
     <p:extLst>
       <p:ext uri="{BB962C8B-B14F-4D97-AF65-F5344CB8AC3E}">
-        <p14:creationId xmlns:p14="http://schemas.microsoft.com/office/powerpoint/2010/main" val="1742197121"/>
+        <p14:creationId xmlns:p14="http://schemas.microsoft.com/office/powerpoint/2010/main" val="1096165223"/>
       </p:ext>
     </p:extLst>
   </p:cSld>
@@ -9797,7 +9851,7 @@
           <p:cNvPr id="18" name="">
             <a:extLst xmlns:a="http://schemas.openxmlformats.org/drawingml/2006/main">
               <a:ext uri="{FF2B5EF4-FFF2-40B4-BE49-F238E27FC236}">
-                <a16:creationId xmlns:a16="http://schemas.microsoft.com/office/drawing/2014/main" id="{ED003869-1379-4E36-BE4F-6CE564638E04}"/>
+                <a16:creationId xmlns:a16="http://schemas.microsoft.com/office/drawing/2014/main" id="{D0527BB9-39C5-46F2-B5B4-D12970BAC5B4}"/>
               </a:ext>
             </a:extLst>
           </p:cNvPr>
@@ -9859,7 +9913,7 @@
           <p:cNvPr id="2" name="">
             <a:extLst xmlns:a="http://schemas.openxmlformats.org/drawingml/2006/main">
               <a:ext uri="{FF2B5EF4-FFF2-40B4-BE49-F238E27FC236}">
-                <a16:creationId xmlns:a16="http://schemas.microsoft.com/office/drawing/2014/main" id="{BD422F80-6785-4F4D-B7DA-61A67CE6C614}"/>
+                <a16:creationId xmlns:a16="http://schemas.microsoft.com/office/drawing/2014/main" id="{1B971D5B-D925-4132-B61A-E672AB0620DB}"/>
               </a:ext>
             </a:extLst>
           </p:cNvPr>
@@ -9921,7 +9975,7 @@
           <p:cNvPr id="3" name="">
             <a:extLst xmlns:a="http://schemas.openxmlformats.org/drawingml/2006/main">
               <a:ext uri="{FF2B5EF4-FFF2-40B4-BE49-F238E27FC236}">
-                <a16:creationId xmlns:a16="http://schemas.microsoft.com/office/drawing/2014/main" id="{CE149FD9-1E03-4BEB-AA1A-3529C77F4B04}"/>
+                <a16:creationId xmlns:a16="http://schemas.microsoft.com/office/drawing/2014/main" id="{B5E7B75E-3BE4-4CFD-94B6-A631B6DB85A5}"/>
               </a:ext>
             </a:extLst>
           </p:cNvPr>
@@ -9983,7 +10037,7 @@
           <p:cNvPr id="4" name="">
             <a:extLst xmlns:a="http://schemas.openxmlformats.org/drawingml/2006/main">
               <a:ext uri="{FF2B5EF4-FFF2-40B4-BE49-F238E27FC236}">
-                <a16:creationId xmlns:a16="http://schemas.microsoft.com/office/drawing/2014/main" id="{76D1A063-BD0F-4A69-A891-C32123597063}"/>
+                <a16:creationId xmlns:a16="http://schemas.microsoft.com/office/drawing/2014/main" id="{F4975942-9411-4D2A-8417-162E5AAD9A62}"/>
               </a:ext>
             </a:extLst>
           </p:cNvPr>
@@ -10014,7 +10068,7 @@
           <p:cNvPr id="5" name="">
             <a:extLst xmlns:a="http://schemas.openxmlformats.org/drawingml/2006/main">
               <a:ext uri="{FF2B5EF4-FFF2-40B4-BE49-F238E27FC236}">
-                <a16:creationId xmlns:a16="http://schemas.microsoft.com/office/drawing/2014/main" id="{D7894DE6-08E6-4591-9768-5398B4509A28}"/>
+                <a16:creationId xmlns:a16="http://schemas.microsoft.com/office/drawing/2014/main" id="{7FBA93A4-5C6A-490E-A661-745FBFEA9654}"/>
               </a:ext>
             </a:extLst>
           </p:cNvPr>
@@ -10076,7 +10130,7 @@
           <p:cNvPr id="6" name="">
             <a:extLst xmlns:a="http://schemas.openxmlformats.org/drawingml/2006/main">
               <a:ext uri="{FF2B5EF4-FFF2-40B4-BE49-F238E27FC236}">
-                <a16:creationId xmlns:a16="http://schemas.microsoft.com/office/drawing/2014/main" id="{9C44AF46-6BB8-4500-A084-7C2164AE5B99}"/>
+                <a16:creationId xmlns:a16="http://schemas.microsoft.com/office/drawing/2014/main" id="{E9018642-AE03-4E45-8703-37F53CACEA2B}"/>
               </a:ext>
             </a:extLst>
           </p:cNvPr>
@@ -10138,7 +10192,7 @@
           <p:cNvPr id="7" name="">
             <a:extLst xmlns:a="http://schemas.openxmlformats.org/drawingml/2006/main">
               <a:ext uri="{FF2B5EF4-FFF2-40B4-BE49-F238E27FC236}">
-                <a16:creationId xmlns:a16="http://schemas.microsoft.com/office/drawing/2014/main" id="{734135B1-6A81-4DC1-8BCB-E8EFB05665DC}"/>
+                <a16:creationId xmlns:a16="http://schemas.microsoft.com/office/drawing/2014/main" id="{DEAADAEF-EFA0-4A40-B502-F9D5F3029360}"/>
               </a:ext>
             </a:extLst>
           </p:cNvPr>
@@ -10200,7 +10254,7 @@
           <p:cNvPr id="8" name="">
             <a:extLst xmlns:a="http://schemas.openxmlformats.org/drawingml/2006/main">
               <a:ext uri="{FF2B5EF4-FFF2-40B4-BE49-F238E27FC236}">
-                <a16:creationId xmlns:a16="http://schemas.microsoft.com/office/drawing/2014/main" id="{5BC4A3A0-059C-41F9-A390-5A8E2E1F9442}"/>
+                <a16:creationId xmlns:a16="http://schemas.microsoft.com/office/drawing/2014/main" id="{378ECEF9-7D43-4140-A9EF-1B8AE0214973}"/>
               </a:ext>
             </a:extLst>
           </p:cNvPr>
@@ -10262,7 +10316,7 @@
           <p:cNvPr id="9" name="">
             <a:extLst xmlns:a="http://schemas.openxmlformats.org/drawingml/2006/main">
               <a:ext uri="{FF2B5EF4-FFF2-40B4-BE49-F238E27FC236}">
-                <a16:creationId xmlns:a16="http://schemas.microsoft.com/office/drawing/2014/main" id="{80005DAD-3FE8-403F-A738-AD8092E9E464}"/>
+                <a16:creationId xmlns:a16="http://schemas.microsoft.com/office/drawing/2014/main" id="{A2409D38-4FA0-4CC6-A088-EDFC40D32142}"/>
               </a:ext>
             </a:extLst>
           </p:cNvPr>
@@ -10293,7 +10347,7 @@
           <p:cNvPr id="10" name="">
             <a:extLst xmlns:a="http://schemas.openxmlformats.org/drawingml/2006/main">
               <a:ext uri="{FF2B5EF4-FFF2-40B4-BE49-F238E27FC236}">
-                <a16:creationId xmlns:a16="http://schemas.microsoft.com/office/drawing/2014/main" id="{F5DFE571-36FA-4D4E-BB3C-E4EC8B44BA67}"/>
+                <a16:creationId xmlns:a16="http://schemas.microsoft.com/office/drawing/2014/main" id="{03596D5A-7616-42F5-A12E-9C5721DFCA20}"/>
               </a:ext>
             </a:extLst>
           </p:cNvPr>
@@ -10355,7 +10409,7 @@
           <p:cNvPr id="11" name="">
             <a:extLst xmlns:a="http://schemas.openxmlformats.org/drawingml/2006/main">
               <a:ext uri="{FF2B5EF4-FFF2-40B4-BE49-F238E27FC236}">
-                <a16:creationId xmlns:a16="http://schemas.microsoft.com/office/drawing/2014/main" id="{EF11F705-F603-44F1-8912-B6610A2E7A31}"/>
+                <a16:creationId xmlns:a16="http://schemas.microsoft.com/office/drawing/2014/main" id="{15A03CC4-933F-4728-8BFA-3373CFB9E014}"/>
               </a:ext>
             </a:extLst>
           </p:cNvPr>
@@ -10417,7 +10471,7 @@
           <p:cNvPr id="12" name="">
             <a:extLst xmlns:a="http://schemas.openxmlformats.org/drawingml/2006/main">
               <a:ext uri="{FF2B5EF4-FFF2-40B4-BE49-F238E27FC236}">
-                <a16:creationId xmlns:a16="http://schemas.microsoft.com/office/drawing/2014/main" id="{D9E71A8C-CA95-489A-A825-E1702D3E4280}"/>
+                <a16:creationId xmlns:a16="http://schemas.microsoft.com/office/drawing/2014/main" id="{74C89041-2FBE-4505-8290-CB53B98E4B3C}"/>
               </a:ext>
             </a:extLst>
           </p:cNvPr>
@@ -10479,7 +10533,7 @@
           <p:cNvPr id="13" name="">
             <a:extLst xmlns:a="http://schemas.openxmlformats.org/drawingml/2006/main">
               <a:ext uri="{FF2B5EF4-FFF2-40B4-BE49-F238E27FC236}">
-                <a16:creationId xmlns:a16="http://schemas.microsoft.com/office/drawing/2014/main" id="{51A7F61D-0BB9-4544-919C-A506F09BB747}"/>
+                <a16:creationId xmlns:a16="http://schemas.microsoft.com/office/drawing/2014/main" id="{DA9F4E85-9A16-4FA0-8489-A80883179BB0}"/>
               </a:ext>
             </a:extLst>
           </p:cNvPr>
@@ -10510,7 +10564,7 @@
           <p:cNvPr id="14" name="">
             <a:extLst xmlns:a="http://schemas.openxmlformats.org/drawingml/2006/main">
               <a:ext uri="{FF2B5EF4-FFF2-40B4-BE49-F238E27FC236}">
-                <a16:creationId xmlns:a16="http://schemas.microsoft.com/office/drawing/2014/main" id="{086CFF83-398F-4BA2-BD73-5229592DF07C}"/>
+                <a16:creationId xmlns:a16="http://schemas.microsoft.com/office/drawing/2014/main" id="{ECB3A209-4FDD-493C-ABDF-2C395EFD3236}"/>
               </a:ext>
             </a:extLst>
           </p:cNvPr>
@@ -10572,7 +10626,7 @@
           <p:cNvPr id="15" name="">
             <a:extLst xmlns:a="http://schemas.openxmlformats.org/drawingml/2006/main">
               <a:ext uri="{FF2B5EF4-FFF2-40B4-BE49-F238E27FC236}">
-                <a16:creationId xmlns:a16="http://schemas.microsoft.com/office/drawing/2014/main" id="{99B88B30-DB1D-4FC0-9E34-E16F336C5492}"/>
+                <a16:creationId xmlns:a16="http://schemas.microsoft.com/office/drawing/2014/main" id="{C35787B7-8D61-46AD-B4B8-296F3783E929}"/>
               </a:ext>
             </a:extLst>
           </p:cNvPr>
@@ -10634,7 +10688,7 @@
           <p:cNvPr id="16" name="">
             <a:extLst xmlns:a="http://schemas.openxmlformats.org/drawingml/2006/main">
               <a:ext uri="{FF2B5EF4-FFF2-40B4-BE49-F238E27FC236}">
-                <a16:creationId xmlns:a16="http://schemas.microsoft.com/office/drawing/2014/main" id="{B38C183D-C29F-4C05-B44F-1C1C248B2003}"/>
+                <a16:creationId xmlns:a16="http://schemas.microsoft.com/office/drawing/2014/main" id="{512F0188-FCD0-4B2B-B39D-660EB77CE5F2}"/>
               </a:ext>
             </a:extLst>
           </p:cNvPr>
@@ -10696,7 +10750,7 @@
           <p:cNvPr id="17" name="">
             <a:extLst xmlns:a="http://schemas.openxmlformats.org/drawingml/2006/main">
               <a:ext uri="{FF2B5EF4-FFF2-40B4-BE49-F238E27FC236}">
-                <a16:creationId xmlns:a16="http://schemas.microsoft.com/office/drawing/2014/main" id="{3669E4B1-891E-4E62-A526-0C8C9A23C9E2}"/>
+                <a16:creationId xmlns:a16="http://schemas.microsoft.com/office/drawing/2014/main" id="{92F10721-9E22-4FEC-BDAA-61EA6D60B82A}"/>
               </a:ext>
             </a:extLst>
           </p:cNvPr>
@@ -10725,7 +10779,7 @@
     </p:spTree>
     <p:extLst>
       <p:ext uri="{BB962C8B-B14F-4D97-AF65-F5344CB8AC3E}">
-        <p14:creationId xmlns:p14="http://schemas.microsoft.com/office/powerpoint/2010/main" val="681227796"/>
+        <p14:creationId xmlns:p14="http://schemas.microsoft.com/office/powerpoint/2010/main" val="1732332417"/>
       </p:ext>
     </p:extLst>
   </p:cSld>
@@ -10756,7 +10810,7 @@
           <p:cNvPr id="22" name="">
             <a:extLst xmlns:a="http://schemas.openxmlformats.org/drawingml/2006/main">
               <a:ext uri="{FF2B5EF4-FFF2-40B4-BE49-F238E27FC236}">
-                <a16:creationId xmlns:a16="http://schemas.microsoft.com/office/drawing/2014/main" id="{B62A5464-6F3D-4329-BB56-03DA32E31019}"/>
+                <a16:creationId xmlns:a16="http://schemas.microsoft.com/office/drawing/2014/main" id="{CDB5DD14-7A88-416F-920C-2AAFDC55AFD0}"/>
               </a:ext>
             </a:extLst>
           </p:cNvPr>
@@ -10818,7 +10872,7 @@
           <p:cNvPr id="2" name="">
             <a:extLst xmlns:a="http://schemas.openxmlformats.org/drawingml/2006/main">
               <a:ext uri="{FF2B5EF4-FFF2-40B4-BE49-F238E27FC236}">
-                <a16:creationId xmlns:a16="http://schemas.microsoft.com/office/drawing/2014/main" id="{826C477B-B697-4932-936C-D57305F805B0}"/>
+                <a16:creationId xmlns:a16="http://schemas.microsoft.com/office/drawing/2014/main" id="{D60BDC3C-AD1A-47EA-8A37-2C9E669E161B}"/>
               </a:ext>
             </a:extLst>
           </p:cNvPr>
@@ -10880,7 +10934,7 @@
           <p:cNvPr id="3" name="">
             <a:extLst xmlns:a="http://schemas.openxmlformats.org/drawingml/2006/main">
               <a:ext uri="{FF2B5EF4-FFF2-40B4-BE49-F238E27FC236}">
-                <a16:creationId xmlns:a16="http://schemas.microsoft.com/office/drawing/2014/main" id="{387DBF77-1058-4C5D-8D19-454D7AF2A080}"/>
+                <a16:creationId xmlns:a16="http://schemas.microsoft.com/office/drawing/2014/main" id="{1CDA18E9-6098-4EBA-A731-A2B2BA891196}"/>
               </a:ext>
             </a:extLst>
           </p:cNvPr>
@@ -10942,7 +10996,7 @@
           <p:cNvPr id="4" name="">
             <a:extLst xmlns:a="http://schemas.openxmlformats.org/drawingml/2006/main">
               <a:ext uri="{FF2B5EF4-FFF2-40B4-BE49-F238E27FC236}">
-                <a16:creationId xmlns:a16="http://schemas.microsoft.com/office/drawing/2014/main" id="{C03497D4-6CCB-46EE-879D-3996FB2C22B9}"/>
+                <a16:creationId xmlns:a16="http://schemas.microsoft.com/office/drawing/2014/main" id="{EFE8A99F-4D77-4D72-9BFF-3986F017EA0D}"/>
               </a:ext>
             </a:extLst>
           </p:cNvPr>
@@ -10973,7 +11027,7 @@
           <p:cNvPr id="5" name="">
             <a:extLst xmlns:a="http://schemas.openxmlformats.org/drawingml/2006/main">
               <a:ext uri="{FF2B5EF4-FFF2-40B4-BE49-F238E27FC236}">
-                <a16:creationId xmlns:a16="http://schemas.microsoft.com/office/drawing/2014/main" id="{1CCF4225-D859-43E8-A5E8-55FB65F744BA}"/>
+                <a16:creationId xmlns:a16="http://schemas.microsoft.com/office/drawing/2014/main" id="{B95F60AC-4768-4380-86F0-07FC74EBB665}"/>
               </a:ext>
             </a:extLst>
           </p:cNvPr>
@@ -11035,7 +11089,7 @@
           <p:cNvPr id="6" name="">
             <a:extLst xmlns:a="http://schemas.openxmlformats.org/drawingml/2006/main">
               <a:ext uri="{FF2B5EF4-FFF2-40B4-BE49-F238E27FC236}">
-                <a16:creationId xmlns:a16="http://schemas.microsoft.com/office/drawing/2014/main" id="{65C40859-BF1A-4492-8D42-F6160990F205}"/>
+                <a16:creationId xmlns:a16="http://schemas.microsoft.com/office/drawing/2014/main" id="{CC98FB7B-3E46-4F34-B301-7C28AB7738D8}"/>
               </a:ext>
             </a:extLst>
           </p:cNvPr>
@@ -11068,7 +11122,7 @@
           <p:cNvPr id="7" name="">
             <a:extLst xmlns:a="http://schemas.openxmlformats.org/drawingml/2006/main">
               <a:ext uri="{FF2B5EF4-FFF2-40B4-BE49-F238E27FC236}">
-                <a16:creationId xmlns:a16="http://schemas.microsoft.com/office/drawing/2014/main" id="{BF6AAB7F-6A5F-497E-99B5-C8491127E156}"/>
+                <a16:creationId xmlns:a16="http://schemas.microsoft.com/office/drawing/2014/main" id="{7799A6A9-7E31-4900-91CA-5B277842B9F2}"/>
               </a:ext>
             </a:extLst>
           </p:cNvPr>
@@ -11130,7 +11184,7 @@
           <p:cNvPr id="8" name="">
             <a:extLst xmlns:a="http://schemas.openxmlformats.org/drawingml/2006/main">
               <a:ext uri="{FF2B5EF4-FFF2-40B4-BE49-F238E27FC236}">
-                <a16:creationId xmlns:a16="http://schemas.microsoft.com/office/drawing/2014/main" id="{01778CD9-DFED-4F4D-A2E5-C0029E51F777}"/>
+                <a16:creationId xmlns:a16="http://schemas.microsoft.com/office/drawing/2014/main" id="{A27D9C34-5584-4DBE-ACDB-6FB1B8CECD8A}"/>
               </a:ext>
             </a:extLst>
           </p:cNvPr>
@@ -11192,7 +11246,7 @@
           <p:cNvPr id="9" name="">
             <a:extLst xmlns:a="http://schemas.openxmlformats.org/drawingml/2006/main">
               <a:ext uri="{FF2B5EF4-FFF2-40B4-BE49-F238E27FC236}">
-                <a16:creationId xmlns:a16="http://schemas.microsoft.com/office/drawing/2014/main" id="{14B74089-BA6A-4F7B-A86F-2D7540AF233B}"/>
+                <a16:creationId xmlns:a16="http://schemas.microsoft.com/office/drawing/2014/main" id="{B26FB79A-70FE-4493-9A3F-B99310CC5A15}"/>
               </a:ext>
             </a:extLst>
           </p:cNvPr>
@@ -11225,7 +11279,7 @@
           <p:cNvPr id="10" name="">
             <a:extLst xmlns:a="http://schemas.openxmlformats.org/drawingml/2006/main">
               <a:ext uri="{FF2B5EF4-FFF2-40B4-BE49-F238E27FC236}">
-                <a16:creationId xmlns:a16="http://schemas.microsoft.com/office/drawing/2014/main" id="{6E320427-0C81-48F7-8FF2-365B156B47DD}"/>
+                <a16:creationId xmlns:a16="http://schemas.microsoft.com/office/drawing/2014/main" id="{D4BA2D85-910D-4425-B552-D354789D81C6}"/>
               </a:ext>
             </a:extLst>
           </p:cNvPr>
@@ -11287,7 +11341,7 @@
           <p:cNvPr id="11" name="">
             <a:extLst xmlns:a="http://schemas.openxmlformats.org/drawingml/2006/main">
               <a:ext uri="{FF2B5EF4-FFF2-40B4-BE49-F238E27FC236}">
-                <a16:creationId xmlns:a16="http://schemas.microsoft.com/office/drawing/2014/main" id="{101EEE3A-299B-463F-8833-E169888721A9}"/>
+                <a16:creationId xmlns:a16="http://schemas.microsoft.com/office/drawing/2014/main" id="{FB7393A4-B81A-441B-99E1-EDB3442BDF0C}"/>
               </a:ext>
             </a:extLst>
           </p:cNvPr>
@@ -11349,7 +11403,7 @@
           <p:cNvPr id="12" name="">
             <a:extLst xmlns:a="http://schemas.openxmlformats.org/drawingml/2006/main">
               <a:ext uri="{FF2B5EF4-FFF2-40B4-BE49-F238E27FC236}">
-                <a16:creationId xmlns:a16="http://schemas.microsoft.com/office/drawing/2014/main" id="{518D186D-F3DA-4DE2-9774-59160B4371F1}"/>
+                <a16:creationId xmlns:a16="http://schemas.microsoft.com/office/drawing/2014/main" id="{F9EB8457-1B07-4275-BD54-F6FCD8CA8F2D}"/>
               </a:ext>
             </a:extLst>
           </p:cNvPr>
@@ -11382,7 +11436,7 @@
           <p:cNvPr id="13" name="">
             <a:extLst xmlns:a="http://schemas.openxmlformats.org/drawingml/2006/main">
               <a:ext uri="{FF2B5EF4-FFF2-40B4-BE49-F238E27FC236}">
-                <a16:creationId xmlns:a16="http://schemas.microsoft.com/office/drawing/2014/main" id="{B95896BB-F462-4C31-968F-9E3084665E3D}"/>
+                <a16:creationId xmlns:a16="http://schemas.microsoft.com/office/drawing/2014/main" id="{92BFAA29-F955-4547-86A6-4AD4FB965397}"/>
               </a:ext>
             </a:extLst>
           </p:cNvPr>
@@ -11444,7 +11498,7 @@
           <p:cNvPr id="14" name="">
             <a:extLst xmlns:a="http://schemas.openxmlformats.org/drawingml/2006/main">
               <a:ext uri="{FF2B5EF4-FFF2-40B4-BE49-F238E27FC236}">
-                <a16:creationId xmlns:a16="http://schemas.microsoft.com/office/drawing/2014/main" id="{441BED18-0F8A-49DB-BCFE-CD0A8E280A87}"/>
+                <a16:creationId xmlns:a16="http://schemas.microsoft.com/office/drawing/2014/main" id="{4610E967-6913-4FB1-B76E-4BFE81CE6641}"/>
               </a:ext>
             </a:extLst>
           </p:cNvPr>
@@ -11506,7 +11560,7 @@
           <p:cNvPr id="15" name="">
             <a:extLst xmlns:a="http://schemas.openxmlformats.org/drawingml/2006/main">
               <a:ext uri="{FF2B5EF4-FFF2-40B4-BE49-F238E27FC236}">
-                <a16:creationId xmlns:a16="http://schemas.microsoft.com/office/drawing/2014/main" id="{32317258-4D9A-4393-A943-324ABA59CDC0}"/>
+                <a16:creationId xmlns:a16="http://schemas.microsoft.com/office/drawing/2014/main" id="{92B5E6B3-8425-4304-9260-BC907DF769A7}"/>
               </a:ext>
             </a:extLst>
           </p:cNvPr>
@@ -11539,7 +11593,7 @@
           <p:cNvPr id="16" name="">
             <a:extLst xmlns:a="http://schemas.openxmlformats.org/drawingml/2006/main">
               <a:ext uri="{FF2B5EF4-FFF2-40B4-BE49-F238E27FC236}">
-                <a16:creationId xmlns:a16="http://schemas.microsoft.com/office/drawing/2014/main" id="{453F87A8-4BEB-43DE-A915-4038370BA06B}"/>
+                <a16:creationId xmlns:a16="http://schemas.microsoft.com/office/drawing/2014/main" id="{AE160BD3-DDAE-4FD7-A034-0B4869E546B6}"/>
               </a:ext>
             </a:extLst>
           </p:cNvPr>
@@ -11601,7 +11655,7 @@
           <p:cNvPr id="17" name="">
             <a:extLst xmlns:a="http://schemas.openxmlformats.org/drawingml/2006/main">
               <a:ext uri="{FF2B5EF4-FFF2-40B4-BE49-F238E27FC236}">
-                <a16:creationId xmlns:a16="http://schemas.microsoft.com/office/drawing/2014/main" id="{475F7A0B-1F40-44AE-B024-84A5CD94322A}"/>
+                <a16:creationId xmlns:a16="http://schemas.microsoft.com/office/drawing/2014/main" id="{A2EE024B-D905-40FE-AF2C-652AF4CC14D2}"/>
               </a:ext>
             </a:extLst>
           </p:cNvPr>
@@ -11738,7 +11792,7 @@
           <p:cNvPr id="21" name="">
             <a:extLst xmlns:a="http://schemas.openxmlformats.org/drawingml/2006/main">
               <a:ext uri="{FF2B5EF4-FFF2-40B4-BE49-F238E27FC236}">
-                <a16:creationId xmlns:a16="http://schemas.microsoft.com/office/drawing/2014/main" id="{5C4AB27B-EA04-460A-BA82-3F94FA9135DF}"/>
+                <a16:creationId xmlns:a16="http://schemas.microsoft.com/office/drawing/2014/main" id="{82235CD9-C6EF-490C-91EC-B98C7528956B}"/>
               </a:ext>
             </a:extLst>
           </p:cNvPr>
@@ -11798,7 +11852,7 @@
     </p:spTree>
     <p:extLst>
       <p:ext uri="{BB962C8B-B14F-4D97-AF65-F5344CB8AC3E}">
-        <p14:creationId xmlns:p14="http://schemas.microsoft.com/office/powerpoint/2010/main" val="2113934689"/>
+        <p14:creationId xmlns:p14="http://schemas.microsoft.com/office/powerpoint/2010/main" val="1277576147"/>
       </p:ext>
     </p:extLst>
   </p:cSld>
@@ -11829,7 +11883,7 @@
           <p:cNvPr id="14" name="">
             <a:extLst xmlns:a="http://schemas.openxmlformats.org/drawingml/2006/main">
               <a:ext uri="{FF2B5EF4-FFF2-40B4-BE49-F238E27FC236}">
-                <a16:creationId xmlns:a16="http://schemas.microsoft.com/office/drawing/2014/main" id="{FF040816-BD5B-4A76-833B-FA6E94475DEA}"/>
+                <a16:creationId xmlns:a16="http://schemas.microsoft.com/office/drawing/2014/main" id="{14E07BB4-65FD-480D-B0F9-C5F52734E30A}"/>
               </a:ext>
             </a:extLst>
           </p:cNvPr>
@@ -11891,7 +11945,7 @@
           <p:cNvPr id="2" name="">
             <a:extLst xmlns:a="http://schemas.openxmlformats.org/drawingml/2006/main">
               <a:ext uri="{FF2B5EF4-FFF2-40B4-BE49-F238E27FC236}">
-                <a16:creationId xmlns:a16="http://schemas.microsoft.com/office/drawing/2014/main" id="{42540FD8-DB8E-45AE-8049-B9D98C40DCCB}"/>
+                <a16:creationId xmlns:a16="http://schemas.microsoft.com/office/drawing/2014/main" id="{E9448BD1-4D45-4AB1-84A2-20EECAE5CBCB}"/>
               </a:ext>
             </a:extLst>
           </p:cNvPr>
@@ -11953,7 +12007,7 @@
           <p:cNvPr id="3" name="">
             <a:extLst xmlns:a="http://schemas.openxmlformats.org/drawingml/2006/main">
               <a:ext uri="{FF2B5EF4-FFF2-40B4-BE49-F238E27FC236}">
-                <a16:creationId xmlns:a16="http://schemas.microsoft.com/office/drawing/2014/main" id="{D4D3CD4B-D8CB-4B46-8F2D-ADD209DE0A46}"/>
+                <a16:creationId xmlns:a16="http://schemas.microsoft.com/office/drawing/2014/main" id="{227F2102-0BDF-48AF-B94F-B7D2EE1870AB}"/>
               </a:ext>
             </a:extLst>
           </p:cNvPr>
@@ -12015,7 +12069,7 @@
           <p:cNvPr id="4" name="">
             <a:extLst xmlns:a="http://schemas.openxmlformats.org/drawingml/2006/main">
               <a:ext uri="{FF2B5EF4-FFF2-40B4-BE49-F238E27FC236}">
-                <a16:creationId xmlns:a16="http://schemas.microsoft.com/office/drawing/2014/main" id="{67DE9899-B8C6-42DA-9F03-9E7FC9D7FB1B}"/>
+                <a16:creationId xmlns:a16="http://schemas.microsoft.com/office/drawing/2014/main" id="{369E965C-5A29-4245-85FD-0B107375591F}"/>
               </a:ext>
             </a:extLst>
           </p:cNvPr>
@@ -12046,7 +12100,7 @@
           <p:cNvPr id="5" name="">
             <a:extLst xmlns:a="http://schemas.openxmlformats.org/drawingml/2006/main">
               <a:ext uri="{FF2B5EF4-FFF2-40B4-BE49-F238E27FC236}">
-                <a16:creationId xmlns:a16="http://schemas.microsoft.com/office/drawing/2014/main" id="{98412EBB-5BEC-478F-9C01-BDA02E3AB2C8}"/>
+                <a16:creationId xmlns:a16="http://schemas.microsoft.com/office/drawing/2014/main" id="{95274C8E-43E7-483D-9706-78BEBC1FCB96}"/>
               </a:ext>
             </a:extLst>
           </p:cNvPr>
@@ -12108,7 +12162,7 @@
           <p:cNvPr id="6" name="">
             <a:extLst xmlns:a="http://schemas.openxmlformats.org/drawingml/2006/main">
               <a:ext uri="{FF2B5EF4-FFF2-40B4-BE49-F238E27FC236}">
-                <a16:creationId xmlns:a16="http://schemas.microsoft.com/office/drawing/2014/main" id="{F437F0A4-5B14-4A33-82BB-9318A344A514}"/>
+                <a16:creationId xmlns:a16="http://schemas.microsoft.com/office/drawing/2014/main" id="{21A2A71B-AEF4-4DF7-9306-225FFB6235C2}"/>
               </a:ext>
             </a:extLst>
           </p:cNvPr>
@@ -12170,7 +12224,7 @@
           <p:cNvPr id="7" name="">
             <a:extLst xmlns:a="http://schemas.openxmlformats.org/drawingml/2006/main">
               <a:ext uri="{FF2B5EF4-FFF2-40B4-BE49-F238E27FC236}">
-                <a16:creationId xmlns:a16="http://schemas.microsoft.com/office/drawing/2014/main" id="{EAB45B7D-E8EB-4697-AA20-4CB701BB6B00}"/>
+                <a16:creationId xmlns:a16="http://schemas.microsoft.com/office/drawing/2014/main" id="{839ADF0F-B1F8-4F4D-8420-CE1CB99E8857}"/>
               </a:ext>
             </a:extLst>
           </p:cNvPr>
@@ -12201,7 +12255,7 @@
           <p:cNvPr id="8" name="">
             <a:extLst xmlns:a="http://schemas.openxmlformats.org/drawingml/2006/main">
               <a:ext uri="{FF2B5EF4-FFF2-40B4-BE49-F238E27FC236}">
-                <a16:creationId xmlns:a16="http://schemas.microsoft.com/office/drawing/2014/main" id="{977B14A8-D13A-4E19-83FD-77026C2139BA}"/>
+                <a16:creationId xmlns:a16="http://schemas.microsoft.com/office/drawing/2014/main" id="{BF880411-93E7-4030-A334-28A9C82048BD}"/>
               </a:ext>
             </a:extLst>
           </p:cNvPr>
@@ -12263,7 +12317,7 @@
           <p:cNvPr id="9" name="">
             <a:extLst xmlns:a="http://schemas.openxmlformats.org/drawingml/2006/main">
               <a:ext uri="{FF2B5EF4-FFF2-40B4-BE49-F238E27FC236}">
-                <a16:creationId xmlns:a16="http://schemas.microsoft.com/office/drawing/2014/main" id="{FCEFFA83-8400-499D-85AF-F21855858A5C}"/>
+                <a16:creationId xmlns:a16="http://schemas.microsoft.com/office/drawing/2014/main" id="{907743F2-9595-4AF7-ACF0-DB8538C6B4F2}"/>
               </a:ext>
             </a:extLst>
           </p:cNvPr>
@@ -12325,7 +12379,7 @@
           <p:cNvPr id="10" name="">
             <a:extLst xmlns:a="http://schemas.openxmlformats.org/drawingml/2006/main">
               <a:ext uri="{FF2B5EF4-FFF2-40B4-BE49-F238E27FC236}">
-                <a16:creationId xmlns:a16="http://schemas.microsoft.com/office/drawing/2014/main" id="{DE3C2082-A677-40FD-83D6-41E778CE5FC0}"/>
+                <a16:creationId xmlns:a16="http://schemas.microsoft.com/office/drawing/2014/main" id="{2BCF8175-EB29-48F6-89D2-759119E45979}"/>
               </a:ext>
             </a:extLst>
           </p:cNvPr>
@@ -12387,7 +12441,7 @@
           <p:cNvPr id="11" name="">
             <a:extLst xmlns:a="http://schemas.openxmlformats.org/drawingml/2006/main">
               <a:ext uri="{FF2B5EF4-FFF2-40B4-BE49-F238E27FC236}">
-                <a16:creationId xmlns:a16="http://schemas.microsoft.com/office/drawing/2014/main" id="{39E5B2B7-082B-45D3-AAC3-C59F46AF9C17}"/>
+                <a16:creationId xmlns:a16="http://schemas.microsoft.com/office/drawing/2014/main" id="{9754EDD1-400E-4029-9436-2100C6650104}"/>
               </a:ext>
             </a:extLst>
           </p:cNvPr>
@@ -12418,7 +12472,7 @@
           <p:cNvPr id="12" name="">
             <a:extLst xmlns:a="http://schemas.openxmlformats.org/drawingml/2006/main">
               <a:ext uri="{FF2B5EF4-FFF2-40B4-BE49-F238E27FC236}">
-                <a16:creationId xmlns:a16="http://schemas.microsoft.com/office/drawing/2014/main" id="{54529DA4-BF2E-4CEF-A18C-906A4C623CB5}"/>
+                <a16:creationId xmlns:a16="http://schemas.microsoft.com/office/drawing/2014/main" id="{60F22EC2-CCA8-41C6-BDCC-FE6B6DC97D39}"/>
               </a:ext>
             </a:extLst>
           </p:cNvPr>
@@ -12480,7 +12534,7 @@
           <p:cNvPr id="13" name="">
             <a:extLst xmlns:a="http://schemas.openxmlformats.org/drawingml/2006/main">
               <a:ext uri="{FF2B5EF4-FFF2-40B4-BE49-F238E27FC236}">
-                <a16:creationId xmlns:a16="http://schemas.microsoft.com/office/drawing/2014/main" id="{BD3B37B3-C395-4C24-860C-9FE7C9F55AC5}"/>
+                <a16:creationId xmlns:a16="http://schemas.microsoft.com/office/drawing/2014/main" id="{ACA94F98-671E-459D-9409-07F9620D3A56}"/>
               </a:ext>
             </a:extLst>
           </p:cNvPr>
@@ -12540,7 +12594,7 @@
     </p:spTree>
     <p:extLst>
       <p:ext uri="{BB962C8B-B14F-4D97-AF65-F5344CB8AC3E}">
-        <p14:creationId xmlns:p14="http://schemas.microsoft.com/office/powerpoint/2010/main" val="1458632192"/>
+        <p14:creationId xmlns:p14="http://schemas.microsoft.com/office/powerpoint/2010/main" val="80208735"/>
       </p:ext>
     </p:extLst>
   </p:cSld>
@@ -12571,7 +12625,7 @@
           <p:cNvPr id="18" name="">
             <a:extLst xmlns:a="http://schemas.openxmlformats.org/drawingml/2006/main">
               <a:ext uri="{FF2B5EF4-FFF2-40B4-BE49-F238E27FC236}">
-                <a16:creationId xmlns:a16="http://schemas.microsoft.com/office/drawing/2014/main" id="{C9F6BA0D-7499-4702-82CE-1A6CB9138FA2}"/>
+                <a16:creationId xmlns:a16="http://schemas.microsoft.com/office/drawing/2014/main" id="{66DD4F4C-5A21-4FFA-A5E7-90DE55B92F90}"/>
               </a:ext>
             </a:extLst>
           </p:cNvPr>
@@ -12633,7 +12687,7 @@
           <p:cNvPr id="2" name="">
             <a:extLst xmlns:a="http://schemas.openxmlformats.org/drawingml/2006/main">
               <a:ext uri="{FF2B5EF4-FFF2-40B4-BE49-F238E27FC236}">
-                <a16:creationId xmlns:a16="http://schemas.microsoft.com/office/drawing/2014/main" id="{01F6702D-E31C-4AB1-8097-849E01E77072}"/>
+                <a16:creationId xmlns:a16="http://schemas.microsoft.com/office/drawing/2014/main" id="{1334DA43-F99D-4640-B216-92411F07FFE5}"/>
               </a:ext>
             </a:extLst>
           </p:cNvPr>
@@ -12695,7 +12749,7 @@
           <p:cNvPr id="3" name="">
             <a:extLst xmlns:a="http://schemas.openxmlformats.org/drawingml/2006/main">
               <a:ext uri="{FF2B5EF4-FFF2-40B4-BE49-F238E27FC236}">
-                <a16:creationId xmlns:a16="http://schemas.microsoft.com/office/drawing/2014/main" id="{56D826FB-BBCE-49A2-BB84-8CB8276928CB}"/>
+                <a16:creationId xmlns:a16="http://schemas.microsoft.com/office/drawing/2014/main" id="{B6209C4A-C58B-4BC0-8DB8-6186C96605C8}"/>
               </a:ext>
             </a:extLst>
           </p:cNvPr>
@@ -12757,7 +12811,7 @@
           <p:cNvPr id="4" name="">
             <a:extLst xmlns:a="http://schemas.openxmlformats.org/drawingml/2006/main">
               <a:ext uri="{FF2B5EF4-FFF2-40B4-BE49-F238E27FC236}">
-                <a16:creationId xmlns:a16="http://schemas.microsoft.com/office/drawing/2014/main" id="{23E2A1F4-A73F-48B5-BDA7-31A4F6C4EB49}"/>
+                <a16:creationId xmlns:a16="http://schemas.microsoft.com/office/drawing/2014/main" id="{E914C3EF-8BC7-46F7-9462-0ABECD164B09}"/>
               </a:ext>
             </a:extLst>
           </p:cNvPr>
@@ -12788,7 +12842,7 @@
           <p:cNvPr id="5" name="">
             <a:extLst xmlns:a="http://schemas.openxmlformats.org/drawingml/2006/main">
               <a:ext uri="{FF2B5EF4-FFF2-40B4-BE49-F238E27FC236}">
-                <a16:creationId xmlns:a16="http://schemas.microsoft.com/office/drawing/2014/main" id="{4C34BDB5-646A-4B73-B487-CE451026CE5D}"/>
+                <a16:creationId xmlns:a16="http://schemas.microsoft.com/office/drawing/2014/main" id="{884D1A16-6035-4797-988A-E21DC90CCDED}"/>
               </a:ext>
             </a:extLst>
           </p:cNvPr>
@@ -12850,7 +12904,7 @@
           <p:cNvPr id="6" name="">
             <a:extLst xmlns:a="http://schemas.openxmlformats.org/drawingml/2006/main">
               <a:ext uri="{FF2B5EF4-FFF2-40B4-BE49-F238E27FC236}">
-                <a16:creationId xmlns:a16="http://schemas.microsoft.com/office/drawing/2014/main" id="{A987EB3B-2D64-4B81-BA13-A2C2F897C322}"/>
+                <a16:creationId xmlns:a16="http://schemas.microsoft.com/office/drawing/2014/main" id="{10F960A9-57FD-46A9-86A1-1B0755B8336C}"/>
               </a:ext>
             </a:extLst>
           </p:cNvPr>
@@ -12912,7 +12966,7 @@
           <p:cNvPr id="7" name="">
             <a:extLst xmlns:a="http://schemas.openxmlformats.org/drawingml/2006/main">
               <a:ext uri="{FF2B5EF4-FFF2-40B4-BE49-F238E27FC236}">
-                <a16:creationId xmlns:a16="http://schemas.microsoft.com/office/drawing/2014/main" id="{685FA588-38E2-4024-955B-AEE6258E2C1C}"/>
+                <a16:creationId xmlns:a16="http://schemas.microsoft.com/office/drawing/2014/main" id="{F6CDE1EA-CF77-42D4-A558-66BD6BD5DB41}"/>
               </a:ext>
             </a:extLst>
           </p:cNvPr>
@@ -12974,7 +13028,7 @@
           <p:cNvPr id="8" name="">
             <a:extLst xmlns:a="http://schemas.openxmlformats.org/drawingml/2006/main">
               <a:ext uri="{FF2B5EF4-FFF2-40B4-BE49-F238E27FC236}">
-                <a16:creationId xmlns:a16="http://schemas.microsoft.com/office/drawing/2014/main" id="{5F57364A-5D8D-41E6-B6A1-BCC428C09BD8}"/>
+                <a16:creationId xmlns:a16="http://schemas.microsoft.com/office/drawing/2014/main" id="{2CCFE5C0-6D6E-4E3C-A065-026D95EE210F}"/>
               </a:ext>
             </a:extLst>
           </p:cNvPr>
@@ -13036,7 +13090,7 @@
           <p:cNvPr id="9" name="">
             <a:extLst xmlns:a="http://schemas.openxmlformats.org/drawingml/2006/main">
               <a:ext uri="{FF2B5EF4-FFF2-40B4-BE49-F238E27FC236}">
-                <a16:creationId xmlns:a16="http://schemas.microsoft.com/office/drawing/2014/main" id="{557A3C66-5A90-4DA4-9D68-BD7EA556A92B}"/>
+                <a16:creationId xmlns:a16="http://schemas.microsoft.com/office/drawing/2014/main" id="{CEA57C7D-1982-4EF4-A943-734A8092EEAE}"/>
               </a:ext>
             </a:extLst>
           </p:cNvPr>
@@ -13067,7 +13121,7 @@
           <p:cNvPr id="10" name="">
             <a:extLst xmlns:a="http://schemas.openxmlformats.org/drawingml/2006/main">
               <a:ext uri="{FF2B5EF4-FFF2-40B4-BE49-F238E27FC236}">
-                <a16:creationId xmlns:a16="http://schemas.microsoft.com/office/drawing/2014/main" id="{8CDBFF49-8E63-459D-8732-3C59F52A22B5}"/>
+                <a16:creationId xmlns:a16="http://schemas.microsoft.com/office/drawing/2014/main" id="{BAA2535B-BFEE-4B30-9482-F35B805B3F0F}"/>
               </a:ext>
             </a:extLst>
           </p:cNvPr>
@@ -13129,7 +13183,7 @@
           <p:cNvPr id="11" name="">
             <a:extLst xmlns:a="http://schemas.openxmlformats.org/drawingml/2006/main">
               <a:ext uri="{FF2B5EF4-FFF2-40B4-BE49-F238E27FC236}">
-                <a16:creationId xmlns:a16="http://schemas.microsoft.com/office/drawing/2014/main" id="{D3F129D6-6CB3-4A10-8FDB-41B3642D3A27}"/>
+                <a16:creationId xmlns:a16="http://schemas.microsoft.com/office/drawing/2014/main" id="{9FBFE801-E7AA-405F-B144-0FBA4BAB637F}"/>
               </a:ext>
             </a:extLst>
           </p:cNvPr>
@@ -13191,7 +13245,7 @@
           <p:cNvPr id="12" name="">
             <a:extLst xmlns:a="http://schemas.openxmlformats.org/drawingml/2006/main">
               <a:ext uri="{FF2B5EF4-FFF2-40B4-BE49-F238E27FC236}">
-                <a16:creationId xmlns:a16="http://schemas.microsoft.com/office/drawing/2014/main" id="{5199ED8D-F3DB-427B-B363-0A74F4C078AA}"/>
+                <a16:creationId xmlns:a16="http://schemas.microsoft.com/office/drawing/2014/main" id="{0AC5E18A-CD18-47B7-86B3-7BDA96932560}"/>
               </a:ext>
             </a:extLst>
           </p:cNvPr>
@@ -13253,7 +13307,7 @@
           <p:cNvPr id="13" name="">
             <a:extLst xmlns:a="http://schemas.openxmlformats.org/drawingml/2006/main">
               <a:ext uri="{FF2B5EF4-FFF2-40B4-BE49-F238E27FC236}">
-                <a16:creationId xmlns:a16="http://schemas.microsoft.com/office/drawing/2014/main" id="{73AD1207-5719-43C0-9321-6D838CC7ECB0}"/>
+                <a16:creationId xmlns:a16="http://schemas.microsoft.com/office/drawing/2014/main" id="{75A43758-F271-4F9F-B89E-72038047221B}"/>
               </a:ext>
             </a:extLst>
           </p:cNvPr>
@@ -13284,7 +13338,7 @@
           <p:cNvPr id="14" name="">
             <a:extLst xmlns:a="http://schemas.openxmlformats.org/drawingml/2006/main">
               <a:ext uri="{FF2B5EF4-FFF2-40B4-BE49-F238E27FC236}">
-                <a16:creationId xmlns:a16="http://schemas.microsoft.com/office/drawing/2014/main" id="{F6833DDB-08B3-4860-A8B6-B2F9665C6D72}"/>
+                <a16:creationId xmlns:a16="http://schemas.microsoft.com/office/drawing/2014/main" id="{00E89850-BE78-49AE-8574-BB5E03384E03}"/>
               </a:ext>
             </a:extLst>
           </p:cNvPr>
@@ -13346,7 +13400,7 @@
           <p:cNvPr id="15" name="">
             <a:extLst xmlns:a="http://schemas.openxmlformats.org/drawingml/2006/main">
               <a:ext uri="{FF2B5EF4-FFF2-40B4-BE49-F238E27FC236}">
-                <a16:creationId xmlns:a16="http://schemas.microsoft.com/office/drawing/2014/main" id="{B335AEC5-E11B-4BDC-BC06-CF487D74ED97}"/>
+                <a16:creationId xmlns:a16="http://schemas.microsoft.com/office/drawing/2014/main" id="{D66ACDC7-9F30-4F15-9A5F-97A61CAE1689}"/>
               </a:ext>
             </a:extLst>
           </p:cNvPr>
@@ -13408,7 +13462,7 @@
           <p:cNvPr id="16" name="">
             <a:extLst xmlns:a="http://schemas.openxmlformats.org/drawingml/2006/main">
               <a:ext uri="{FF2B5EF4-FFF2-40B4-BE49-F238E27FC236}">
-                <a16:creationId xmlns:a16="http://schemas.microsoft.com/office/drawing/2014/main" id="{40FB54BE-EBA0-4F63-8360-A0F1244B9F3F}"/>
+                <a16:creationId xmlns:a16="http://schemas.microsoft.com/office/drawing/2014/main" id="{B240A7C4-E3EF-46B1-AC82-72627D9A0CE7}"/>
               </a:ext>
             </a:extLst>
           </p:cNvPr>
@@ -13470,7 +13524,7 @@
           <p:cNvPr id="17" name="">
             <a:extLst xmlns:a="http://schemas.openxmlformats.org/drawingml/2006/main">
               <a:ext uri="{FF2B5EF4-FFF2-40B4-BE49-F238E27FC236}">
-                <a16:creationId xmlns:a16="http://schemas.microsoft.com/office/drawing/2014/main" id="{2628776C-D57A-4C7F-AEAB-5A8F8C6681CD}"/>
+                <a16:creationId xmlns:a16="http://schemas.microsoft.com/office/drawing/2014/main" id="{75539E6B-3229-4B58-8BBF-4E1E8AAC5276}"/>
               </a:ext>
             </a:extLst>
           </p:cNvPr>
@@ -13499,7 +13553,7 @@
     </p:spTree>
     <p:extLst>
       <p:ext uri="{BB962C8B-B14F-4D97-AF65-F5344CB8AC3E}">
-        <p14:creationId xmlns:p14="http://schemas.microsoft.com/office/powerpoint/2010/main" val="28705106"/>
+        <p14:creationId xmlns:p14="http://schemas.microsoft.com/office/powerpoint/2010/main" val="526132399"/>
       </p:ext>
     </p:extLst>
   </p:cSld>
@@ -13530,7 +13584,7 @@
           <p:cNvPr id="21" name="">
             <a:extLst xmlns:a="http://schemas.openxmlformats.org/drawingml/2006/main">
               <a:ext uri="{FF2B5EF4-FFF2-40B4-BE49-F238E27FC236}">
-                <a16:creationId xmlns:a16="http://schemas.microsoft.com/office/drawing/2014/main" id="{3534B728-6E72-4B3A-B1C5-9E0E94C9C994}"/>
+                <a16:creationId xmlns:a16="http://schemas.microsoft.com/office/drawing/2014/main" id="{3B5BD705-3E0D-436D-B1DB-23EB75921D22}"/>
               </a:ext>
             </a:extLst>
           </p:cNvPr>
@@ -13592,7 +13646,7 @@
           <p:cNvPr id="2" name="">
             <a:extLst xmlns:a="http://schemas.openxmlformats.org/drawingml/2006/main">
               <a:ext uri="{FF2B5EF4-FFF2-40B4-BE49-F238E27FC236}">
-                <a16:creationId xmlns:a16="http://schemas.microsoft.com/office/drawing/2014/main" id="{E7F82FB8-AD9B-4F9B-98EF-FA0C72AC492C}"/>
+                <a16:creationId xmlns:a16="http://schemas.microsoft.com/office/drawing/2014/main" id="{91CEBFE2-3EFA-4BA7-8F96-88C4C45082E1}"/>
               </a:ext>
             </a:extLst>
           </p:cNvPr>
@@ -13654,7 +13708,7 @@
           <p:cNvPr id="3" name="">
             <a:extLst xmlns:a="http://schemas.openxmlformats.org/drawingml/2006/main">
               <a:ext uri="{FF2B5EF4-FFF2-40B4-BE49-F238E27FC236}">
-                <a16:creationId xmlns:a16="http://schemas.microsoft.com/office/drawing/2014/main" id="{68075859-6A3C-4697-AC94-FA3234AEDA86}"/>
+                <a16:creationId xmlns:a16="http://schemas.microsoft.com/office/drawing/2014/main" id="{814FDE5F-AB8C-4AC2-9752-E7A1993B74C7}"/>
               </a:ext>
             </a:extLst>
           </p:cNvPr>
@@ -13716,7 +13770,7 @@
           <p:cNvPr id="4" name="">
             <a:extLst xmlns:a="http://schemas.openxmlformats.org/drawingml/2006/main">
               <a:ext uri="{FF2B5EF4-FFF2-40B4-BE49-F238E27FC236}">
-                <a16:creationId xmlns:a16="http://schemas.microsoft.com/office/drawing/2014/main" id="{7F3B1DC0-ADF0-463A-B457-65CC16C4023A}"/>
+                <a16:creationId xmlns:a16="http://schemas.microsoft.com/office/drawing/2014/main" id="{CADB9305-2732-41B4-B462-ADB9F89EE088}"/>
               </a:ext>
             </a:extLst>
           </p:cNvPr>
@@ -13747,7 +13801,7 @@
           <p:cNvPr id="5" name="">
             <a:extLst xmlns:a="http://schemas.openxmlformats.org/drawingml/2006/main">
               <a:ext uri="{FF2B5EF4-FFF2-40B4-BE49-F238E27FC236}">
-                <a16:creationId xmlns:a16="http://schemas.microsoft.com/office/drawing/2014/main" id="{7FFD2442-F9EE-4FB9-9D45-B4D05048F027}"/>
+                <a16:creationId xmlns:a16="http://schemas.microsoft.com/office/drawing/2014/main" id="{B1743CB5-13E3-4276-9DA7-44156751244B}"/>
               </a:ext>
             </a:extLst>
           </p:cNvPr>
@@ -13809,7 +13863,7 @@
           <p:cNvPr id="6" name="">
             <a:extLst xmlns:a="http://schemas.openxmlformats.org/drawingml/2006/main">
               <a:ext uri="{FF2B5EF4-FFF2-40B4-BE49-F238E27FC236}">
-                <a16:creationId xmlns:a16="http://schemas.microsoft.com/office/drawing/2014/main" id="{D1DF4C3E-8E15-4BDC-A458-0208B931CD2E}"/>
+                <a16:creationId xmlns:a16="http://schemas.microsoft.com/office/drawing/2014/main" id="{CF4DF68F-9B88-4C47-9A54-3D30F7EFFEC2}"/>
               </a:ext>
             </a:extLst>
           </p:cNvPr>
@@ -13842,7 +13896,7 @@
           <p:cNvPr id="7" name="">
             <a:extLst xmlns:a="http://schemas.openxmlformats.org/drawingml/2006/main">
               <a:ext uri="{FF2B5EF4-FFF2-40B4-BE49-F238E27FC236}">
-                <a16:creationId xmlns:a16="http://schemas.microsoft.com/office/drawing/2014/main" id="{33C8692A-331B-44F5-8671-391EE5BCCED5}"/>
+                <a16:creationId xmlns:a16="http://schemas.microsoft.com/office/drawing/2014/main" id="{04A7DCBC-4CDD-40C2-A83F-8DB2820F9711}"/>
               </a:ext>
             </a:extLst>
           </p:cNvPr>
@@ -13904,7 +13958,7 @@
           <p:cNvPr id="8" name="">
             <a:extLst xmlns:a="http://schemas.openxmlformats.org/drawingml/2006/main">
               <a:ext uri="{FF2B5EF4-FFF2-40B4-BE49-F238E27FC236}">
-                <a16:creationId xmlns:a16="http://schemas.microsoft.com/office/drawing/2014/main" id="{E69DD964-5B1A-4C06-8727-42A76DF45DF2}"/>
+                <a16:creationId xmlns:a16="http://schemas.microsoft.com/office/drawing/2014/main" id="{16386F61-4647-40FE-9B09-89CA116A5338}"/>
               </a:ext>
             </a:extLst>
           </p:cNvPr>
@@ -13966,7 +14020,7 @@
           <p:cNvPr id="9" name="">
             <a:extLst xmlns:a="http://schemas.openxmlformats.org/drawingml/2006/main">
               <a:ext uri="{FF2B5EF4-FFF2-40B4-BE49-F238E27FC236}">
-                <a16:creationId xmlns:a16="http://schemas.microsoft.com/office/drawing/2014/main" id="{BBAEB76E-ACE0-4460-926A-146DF70CC3C6}"/>
+                <a16:creationId xmlns:a16="http://schemas.microsoft.com/office/drawing/2014/main" id="{3D44A8B0-E756-477C-AD87-F6DA7F6BEC1F}"/>
               </a:ext>
             </a:extLst>
           </p:cNvPr>
@@ -13999,7 +14053,7 @@
           <p:cNvPr id="10" name="">
             <a:extLst xmlns:a="http://schemas.openxmlformats.org/drawingml/2006/main">
               <a:ext uri="{FF2B5EF4-FFF2-40B4-BE49-F238E27FC236}">
-                <a16:creationId xmlns:a16="http://schemas.microsoft.com/office/drawing/2014/main" id="{961BF15B-27F2-44A1-9D62-6AB63826A8B5}"/>
+                <a16:creationId xmlns:a16="http://schemas.microsoft.com/office/drawing/2014/main" id="{0F163747-C542-491D-BB94-C01CF7EF2638}"/>
               </a:ext>
             </a:extLst>
           </p:cNvPr>
@@ -14061,7 +14115,7 @@
           <p:cNvPr id="11" name="">
             <a:extLst xmlns:a="http://schemas.openxmlformats.org/drawingml/2006/main">
               <a:ext uri="{FF2B5EF4-FFF2-40B4-BE49-F238E27FC236}">
-                <a16:creationId xmlns:a16="http://schemas.microsoft.com/office/drawing/2014/main" id="{29A02CD3-87FD-4505-B24A-0CED84470698}"/>
+                <a16:creationId xmlns:a16="http://schemas.microsoft.com/office/drawing/2014/main" id="{37051417-66F0-47B1-9441-943869D375B7}"/>
               </a:ext>
             </a:extLst>
           </p:cNvPr>
@@ -14123,7 +14177,7 @@
           <p:cNvPr id="12" name="">
             <a:extLst xmlns:a="http://schemas.openxmlformats.org/drawingml/2006/main">
               <a:ext uri="{FF2B5EF4-FFF2-40B4-BE49-F238E27FC236}">
-                <a16:creationId xmlns:a16="http://schemas.microsoft.com/office/drawing/2014/main" id="{923A868C-3DDC-4841-82EF-876286A7E1A5}"/>
+                <a16:creationId xmlns:a16="http://schemas.microsoft.com/office/drawing/2014/main" id="{BAB41E8F-3B43-4495-8469-59723DB41419}"/>
               </a:ext>
             </a:extLst>
           </p:cNvPr>
@@ -14156,7 +14210,7 @@
           <p:cNvPr id="13" name="">
             <a:extLst xmlns:a="http://schemas.openxmlformats.org/drawingml/2006/main">
               <a:ext uri="{FF2B5EF4-FFF2-40B4-BE49-F238E27FC236}">
-                <a16:creationId xmlns:a16="http://schemas.microsoft.com/office/drawing/2014/main" id="{847CE8F0-3D05-4D32-9639-A740647C2D62}"/>
+                <a16:creationId xmlns:a16="http://schemas.microsoft.com/office/drawing/2014/main" id="{42A8747E-628F-44DB-807A-CA1F17FFE46A}"/>
               </a:ext>
             </a:extLst>
           </p:cNvPr>
@@ -14218,7 +14272,7 @@
           <p:cNvPr id="14" name="">
             <a:extLst xmlns:a="http://schemas.openxmlformats.org/drawingml/2006/main">
               <a:ext uri="{FF2B5EF4-FFF2-40B4-BE49-F238E27FC236}">
-                <a16:creationId xmlns:a16="http://schemas.microsoft.com/office/drawing/2014/main" id="{10421FB3-679E-4F39-B1C6-8F0FA80618BB}"/>
+                <a16:creationId xmlns:a16="http://schemas.microsoft.com/office/drawing/2014/main" id="{8041B881-6F3B-49AF-80E5-D472260DD33B}"/>
               </a:ext>
             </a:extLst>
           </p:cNvPr>
@@ -14280,7 +14334,7 @@
           <p:cNvPr id="15" name="">
             <a:extLst xmlns:a="http://schemas.openxmlformats.org/drawingml/2006/main">
               <a:ext uri="{FF2B5EF4-FFF2-40B4-BE49-F238E27FC236}">
-                <a16:creationId xmlns:a16="http://schemas.microsoft.com/office/drawing/2014/main" id="{FF7A8F1A-1DEF-411C-870F-46113BD27FA5}"/>
+                <a16:creationId xmlns:a16="http://schemas.microsoft.com/office/drawing/2014/main" id="{FE40CE69-B2E0-4615-8853-5EC0A77C342D}"/>
               </a:ext>
             </a:extLst>
           </p:cNvPr>
@@ -14313,7 +14367,7 @@
           <p:cNvPr id="16" name="">
             <a:extLst xmlns:a="http://schemas.openxmlformats.org/drawingml/2006/main">
               <a:ext uri="{FF2B5EF4-FFF2-40B4-BE49-F238E27FC236}">
-                <a16:creationId xmlns:a16="http://schemas.microsoft.com/office/drawing/2014/main" id="{7B8DEAA8-0560-434B-86EC-7FA923053F66}"/>
+                <a16:creationId xmlns:a16="http://schemas.microsoft.com/office/drawing/2014/main" id="{BA881EAB-3D74-4D18-AFB1-10F6D7C8CEA2}"/>
               </a:ext>
             </a:extLst>
           </p:cNvPr>
@@ -14375,7 +14429,7 @@
           <p:cNvPr id="17" name="">
             <a:extLst xmlns:a="http://schemas.openxmlformats.org/drawingml/2006/main">
               <a:ext uri="{FF2B5EF4-FFF2-40B4-BE49-F238E27FC236}">
-                <a16:creationId xmlns:a16="http://schemas.microsoft.com/office/drawing/2014/main" id="{A666FE5D-42F2-45B1-A735-7C18BE746761}"/>
+                <a16:creationId xmlns:a16="http://schemas.microsoft.com/office/drawing/2014/main" id="{D11FAC55-FB86-4075-888A-9D35EA98031E}"/>
               </a:ext>
             </a:extLst>
           </p:cNvPr>
@@ -14510,7 +14564,7 @@
     </p:spTree>
     <p:extLst>
       <p:ext uri="{BB962C8B-B14F-4D97-AF65-F5344CB8AC3E}">
-        <p14:creationId xmlns:p14="http://schemas.microsoft.com/office/powerpoint/2010/main" val="761514227"/>
+        <p14:creationId xmlns:p14="http://schemas.microsoft.com/office/powerpoint/2010/main" val="1934892752"/>
       </p:ext>
     </p:extLst>
   </p:cSld>
@@ -14541,7 +14595,7 @@
           <p:cNvPr id="8" name="">
             <a:extLst xmlns:a="http://schemas.openxmlformats.org/drawingml/2006/main">
               <a:ext uri="{FF2B5EF4-FFF2-40B4-BE49-F238E27FC236}">
-                <a16:creationId xmlns:a16="http://schemas.microsoft.com/office/drawing/2014/main" id="{0EE38ED1-093C-49D2-958E-26D02B957A2E}"/>
+                <a16:creationId xmlns:a16="http://schemas.microsoft.com/office/drawing/2014/main" id="{2AAC9878-1F71-4E9A-9114-F2BA1E455E52}"/>
               </a:ext>
             </a:extLst>
           </p:cNvPr>
@@ -14603,7 +14657,7 @@
           <p:cNvPr id="2" name="">
             <a:extLst xmlns:a="http://schemas.openxmlformats.org/drawingml/2006/main">
               <a:ext uri="{FF2B5EF4-FFF2-40B4-BE49-F238E27FC236}">
-                <a16:creationId xmlns:a16="http://schemas.microsoft.com/office/drawing/2014/main" id="{CFAC3E55-9063-4DCE-8E79-747BF0385489}"/>
+                <a16:creationId xmlns:a16="http://schemas.microsoft.com/office/drawing/2014/main" id="{5147BEE8-9F4F-4ECA-920D-02DAFEFA6431}"/>
               </a:ext>
             </a:extLst>
           </p:cNvPr>
@@ -14665,7 +14719,7 @@
           <p:cNvPr id="3" name="">
             <a:extLst xmlns:a="http://schemas.openxmlformats.org/drawingml/2006/main">
               <a:ext uri="{FF2B5EF4-FFF2-40B4-BE49-F238E27FC236}">
-                <a16:creationId xmlns:a16="http://schemas.microsoft.com/office/drawing/2014/main" id="{D1666365-0BF4-4AB5-9A30-A1AE5CBB20FE}"/>
+                <a16:creationId xmlns:a16="http://schemas.microsoft.com/office/drawing/2014/main" id="{2D30EF89-4A02-46F6-A5CF-B3A86A74ACC5}"/>
               </a:ext>
             </a:extLst>
           </p:cNvPr>
@@ -14727,7 +14781,7 @@
           <p:cNvPr id="4" name="">
             <a:extLst xmlns:a="http://schemas.openxmlformats.org/drawingml/2006/main">
               <a:ext uri="{FF2B5EF4-FFF2-40B4-BE49-F238E27FC236}">
-                <a16:creationId xmlns:a16="http://schemas.microsoft.com/office/drawing/2014/main" id="{82FE58DD-5861-48CF-A551-E292DD02FFC5}"/>
+                <a16:creationId xmlns:a16="http://schemas.microsoft.com/office/drawing/2014/main" id="{DCD4B01D-2A70-470D-9761-B1510549F48B}"/>
               </a:ext>
             </a:extLst>
           </p:cNvPr>
@@ -14758,7 +14812,7 @@
           <p:cNvPr id="5" name="">
             <a:extLst xmlns:a="http://schemas.openxmlformats.org/drawingml/2006/main">
               <a:ext uri="{FF2B5EF4-FFF2-40B4-BE49-F238E27FC236}">
-                <a16:creationId xmlns:a16="http://schemas.microsoft.com/office/drawing/2014/main" id="{D3F62FE5-EA5F-497B-93DE-A17E5D1114B4}"/>
+                <a16:creationId xmlns:a16="http://schemas.microsoft.com/office/drawing/2014/main" id="{B461CFD6-F101-42B7-B447-12044ED439D8}"/>
               </a:ext>
             </a:extLst>
           </p:cNvPr>
@@ -15058,7 +15112,7 @@
           <p:cNvPr id="7" name="">
             <a:extLst xmlns:a="http://schemas.openxmlformats.org/drawingml/2006/main">
               <a:ext uri="{FF2B5EF4-FFF2-40B4-BE49-F238E27FC236}">
-                <a16:creationId xmlns:a16="http://schemas.microsoft.com/office/drawing/2014/main" id="{752E693A-DE7F-4206-B4F0-FE9DD79F12BF}"/>
+                <a16:creationId xmlns:a16="http://schemas.microsoft.com/office/drawing/2014/main" id="{D9DC1906-1CCC-4937-8EC0-B07A849F1F70}"/>
               </a:ext>
             </a:extLst>
           </p:cNvPr>
@@ -15118,7 +15172,7 @@
     </p:spTree>
     <p:extLst>
       <p:ext uri="{BB962C8B-B14F-4D97-AF65-F5344CB8AC3E}">
-        <p14:creationId xmlns:p14="http://schemas.microsoft.com/office/powerpoint/2010/main" val="37344605"/>
+        <p14:creationId xmlns:p14="http://schemas.microsoft.com/office/powerpoint/2010/main" val="737116815"/>
       </p:ext>
     </p:extLst>
   </p:cSld>
@@ -15149,7 +15203,7 @@
           <p:cNvPr id="7" name="">
             <a:extLst xmlns:a="http://schemas.openxmlformats.org/drawingml/2006/main">
               <a:ext uri="{FF2B5EF4-FFF2-40B4-BE49-F238E27FC236}">
-                <a16:creationId xmlns:a16="http://schemas.microsoft.com/office/drawing/2014/main" id="{EFC1CFF5-27A3-413C-9267-D5E83AF642C7}"/>
+                <a16:creationId xmlns:a16="http://schemas.microsoft.com/office/drawing/2014/main" id="{44D9E1D2-9A98-43F6-B570-DB79B6F63FCA}"/>
               </a:ext>
             </a:extLst>
           </p:cNvPr>
@@ -15211,7 +15265,7 @@
           <p:cNvPr id="2" name="">
             <a:extLst xmlns:a="http://schemas.openxmlformats.org/drawingml/2006/main">
               <a:ext uri="{FF2B5EF4-FFF2-40B4-BE49-F238E27FC236}">
-                <a16:creationId xmlns:a16="http://schemas.microsoft.com/office/drawing/2014/main" id="{BB7B5BD5-50AF-4667-BC9A-F2F5D27EF857}"/>
+                <a16:creationId xmlns:a16="http://schemas.microsoft.com/office/drawing/2014/main" id="{6E1CD020-469B-46A5-8FDE-2C5C721640A1}"/>
               </a:ext>
             </a:extLst>
           </p:cNvPr>
@@ -15273,7 +15327,7 @@
           <p:cNvPr id="3" name="">
             <a:extLst xmlns:a="http://schemas.openxmlformats.org/drawingml/2006/main">
               <a:ext uri="{FF2B5EF4-FFF2-40B4-BE49-F238E27FC236}">
-                <a16:creationId xmlns:a16="http://schemas.microsoft.com/office/drawing/2014/main" id="{60E6085D-C466-4B0F-8B55-D1F3906FB205}"/>
+                <a16:creationId xmlns:a16="http://schemas.microsoft.com/office/drawing/2014/main" id="{F0334367-E066-4894-878B-814176530479}"/>
               </a:ext>
             </a:extLst>
           </p:cNvPr>
@@ -15335,7 +15389,7 @@
           <p:cNvPr id="4" name="">
             <a:extLst xmlns:a="http://schemas.openxmlformats.org/drawingml/2006/main">
               <a:ext uri="{FF2B5EF4-FFF2-40B4-BE49-F238E27FC236}">
-                <a16:creationId xmlns:a16="http://schemas.microsoft.com/office/drawing/2014/main" id="{34F6405E-42EC-4109-8A76-C8A22811BA83}"/>
+                <a16:creationId xmlns:a16="http://schemas.microsoft.com/office/drawing/2014/main" id="{8C18AB6F-8A6D-460A-983F-7E491C202679}"/>
               </a:ext>
             </a:extLst>
           </p:cNvPr>
@@ -15366,7 +15420,7 @@
           <p:cNvPr id="5" name="">
             <a:extLst xmlns:a="http://schemas.openxmlformats.org/drawingml/2006/main">
               <a:ext uri="{FF2B5EF4-FFF2-40B4-BE49-F238E27FC236}">
-                <a16:creationId xmlns:a16="http://schemas.microsoft.com/office/drawing/2014/main" id="{3495B2E1-159F-41F7-8F3B-8852E469EF22}"/>
+                <a16:creationId xmlns:a16="http://schemas.microsoft.com/office/drawing/2014/main" id="{51B6A475-83F6-4EF6-8F29-92158143E425}"/>
               </a:ext>
             </a:extLst>
           </p:cNvPr>
@@ -15826,7 +15880,7 @@
     </p:spTree>
     <p:extLst>
       <p:ext uri="{BB962C8B-B14F-4D97-AF65-F5344CB8AC3E}">
-        <p14:creationId xmlns:p14="http://schemas.microsoft.com/office/powerpoint/2010/main" val="880701237"/>
+        <p14:creationId xmlns:p14="http://schemas.microsoft.com/office/powerpoint/2010/main" val="1537415173"/>
       </p:ext>
     </p:extLst>
   </p:cSld>

</xml_diff>